<commit_message>
Correct affiliation to Geoscience Research Group, Departemen Fisika
Replace "Departemen Geofisika" with "Geoscience Research Group, Departemen
Fisika, FMIPA UGM" on the Flores talk page (Peran + footer) and the deck
(title + closing slides); regenerate PDF and PPTX from the corrected deck.

Co-Authored-By: Claude Opus 4.8 <noreply@anthropic.com>
</commit_message>
<xml_diff>
--- a/.design/design-system/elegant-minimalist/outputs/talk-flores-2026/Diskusi_Publik_Gempa_Flores_2026_Wiwit_Suryanto.pptx
+++ b/.design/design-system/elegant-minimalist/outputs/talk-flores-2026/Diskusi_Publik_Gempa_Flores_2026_Wiwit_Suryanto.pptx
@@ -3351,7 +3351,7 @@
                 </a:solidFill>
                 <a:latin typeface="Inter"/>
               </a:rPr>
-              <a:t>Dr.rer.nat. Wiwit Suryanto — Departemen Geofisika, FMIPA UGM</a:t>
+              <a:t>Dr.rer.nat. Wiwit Suryanto — Geoscience Research Group, Departemen Fisika, FMIPA UGM</a:t>
             </a:r>
           </a:p>
         </p:txBody>
@@ -7960,7 +7960,7 @@
                 </a:solidFill>
                 <a:latin typeface="Inter"/>
               </a:rPr>
-              <a:t>  ·  Departemen Geofisika, FMIPA UGM  ·  Terima kasih.</a:t>
+              <a:t>  ·  Geoscience Research Group, Departemen Fisika, FMIPA UGM  ·  Terima kasih.</a:t>
             </a:r>
           </a:p>
         </p:txBody>

</xml_diff>

<commit_message>
Reword talk closing slide for clarity
Replace the awkward "memperpendek jarak antara guncangan dan keselamatan"
with "memperbesar peluang kita selamat saat gempa berikutnya datang" on the
closing slide; regenerate PDF and PPTX.

Co-Authored-By: Claude Opus 4.8 <noreply@anthropic.com>
</commit_message>
<xml_diff>
--- a/.design/design-system/elegant-minimalist/outputs/talk-flores-2026/Diskusi_Publik_Gempa_Flores_2026_Wiwit_Suryanto.pptx
+++ b/.design/design-system/elegant-minimalist/outputs/talk-flores-2026/Diskusi_Publik_Gempa_Flores_2026_Wiwit_Suryanto.pptx
@@ -7899,7 +7899,7 @@
                 </a:solidFill>
                 <a:latin typeface="Inter"/>
               </a:rPr>
-              <a:t>Kita tak bisa mencegah gempa. Tapi setiap sensor tambahan, setiap warga yang tahu harus </a:t>
+              <a:t>Kita tak bisa mencegah gempa. Tapi setiap sensor tambahan dan setiap warga yang tahu harus </a:t>
             </a:r>
             <a:r>
               <a:rPr sz="1600" b="1" i="0">
@@ -7908,7 +7908,7 @@
                 </a:solidFill>
                 <a:latin typeface="Inter"/>
               </a:rPr>
-              <a:t>lari ke tempat tinggi</a:t>
+              <a:t>segera lari ke tempat tinggi</a:t>
             </a:r>
             <a:r>
               <a:rPr sz="1600" b="0" i="0">
@@ -7917,7 +7917,7 @@
                 </a:solidFill>
                 <a:latin typeface="Inter"/>
               </a:rPr>
-              <a:t>, memperpendek jarak antara guncangan dan keselamatan.</a:t>
+              <a:t> memperbesar peluang kita selamat saat gempa berikutnya datang.</a:t>
             </a:r>
           </a:p>
         </p:txBody>

</xml_diff>

<commit_message>
Add historical (pre-instrumental) earthquake slide to Flores talk
New slide 6/10 from Arthur Wichmann's Indies earthquake catalogue (Solor 1648,
seaquake N of Flores 1837, Nanga Rama 1855 wave, Ambugaga/Ende 1868), carrying
the message: the hazard was recorded long before seismographs — 2026 confirms
it, and vigilance is now essential. Notes the macroseismic records cannot be
assigned magnitudes or tied to the same fault. Renumber deck footers to /10,
regenerate PDF and PPTX, and add a matching summary bullet on the talk page.

Co-Authored-By: Claude Opus 4.8 <noreply@anthropic.com>
</commit_message>
<xml_diff>
--- a/.design/design-system/elegant-minimalist/outputs/talk-flores-2026/Diskusi_Publik_Gempa_Flores_2026_Wiwit_Suryanto.pptx
+++ b/.design/design-system/elegant-minimalist/outputs/talk-flores-2026/Diskusi_Publik_Gempa_Flores_2026_Wiwit_Suryanto.pptx
@@ -14,6 +14,7 @@
     <p:sldId id="262" r:id="rId13"/>
     <p:sldId id="263" r:id="rId14"/>
     <p:sldId id="264" r:id="rId15"/>
+    <p:sldId id="265" r:id="rId16"/>
   </p:sldIdLst>
   <p:sldSz cx="12191695" cy="6858000" type="screen4x3"/>
   <p:notesSz cx="6858000" cy="9144000"/>
@@ -3386,7 +3387,535 @@
                 </a:solidFill>
                 <a:latin typeface="Inter"/>
               </a:rPr>
-              <a:t>1 / 9</a:t>
+              <a:t>1 / 10</a:t>
+            </a:r>
+          </a:p>
+        </p:txBody>
+      </p:sp>
+    </p:spTree>
+  </p:cSld>
+  <p:clrMapOvr>
+    <a:masterClrMapping/>
+  </p:clrMapOvr>
+</p:sld>
+</file>
+
+<file path=ppt/slides/slide10.xml><?xml version="1.0" encoding="utf-8"?>
+<p:sld xmlns:a="http://schemas.openxmlformats.org/drawingml/2006/main" xmlns:p="http://schemas.openxmlformats.org/presentationml/2006/main" xmlns:r="http://schemas.openxmlformats.org/officeDocument/2006/relationships">
+  <p:cSld>
+    <p:spTree>
+      <p:nvGrpSpPr>
+        <p:cNvPr id="1" name=""/>
+        <p:cNvGrpSpPr/>
+        <p:nvPr/>
+      </p:nvGrpSpPr>
+      <p:grpSpPr/>
+      <p:sp>
+        <p:nvSpPr>
+          <p:cNvPr id="2" name="Rectangle 1"/>
+          <p:cNvSpPr/>
+          <p:nvPr/>
+        </p:nvSpPr>
+        <p:spPr>
+          <a:xfrm>
+            <a:off x="0" y="0"/>
+            <a:ext cx="12191695" cy="6858000"/>
+          </a:xfrm>
+          <a:prstGeom prst="rect">
+            <a:avLst/>
+          </a:prstGeom>
+          <a:solidFill>
+            <a:srgbClr val="F8F6F1"/>
+          </a:solidFill>
+          <a:ln>
+            <a:noFill/>
+          </a:ln>
+          <a:effectLst/>
+        </p:spPr>
+        <p:style>
+          <a:lnRef idx="1">
+            <a:schemeClr val="accent1"/>
+          </a:lnRef>
+          <a:fillRef idx="3">
+            <a:schemeClr val="accent1"/>
+          </a:fillRef>
+          <a:effectRef idx="2">
+            <a:schemeClr val="accent1"/>
+          </a:effectRef>
+          <a:fontRef idx="minor">
+            <a:schemeClr val="lt1"/>
+          </a:fontRef>
+        </p:style>
+        <p:txBody>
+          <a:bodyPr rtlCol="0" anchor="ctr"/>
+          <a:lstStyle/>
+          <a:p>
+            <a:pPr algn="ctr"/>
+          </a:p>
+        </p:txBody>
+      </p:sp>
+      <p:sp>
+        <p:nvSpPr>
+          <p:cNvPr id="3" name="TextBox 2"/>
+          <p:cNvSpPr txBox="1"/>
+          <p:nvPr/>
+        </p:nvSpPr>
+        <p:spPr>
+          <a:xfrm>
+            <a:off x="566928" y="457200"/>
+            <a:ext cx="10058400" cy="365760"/>
+          </a:xfrm>
+          <a:prstGeom prst="rect">
+            <a:avLst/>
+          </a:prstGeom>
+          <a:noFill/>
+        </p:spPr>
+        <p:txBody>
+          <a:bodyPr wrap="square" anchor="t" lIns="0" rIns="0" tIns="0" bIns="0">
+            <a:spAutoFit/>
+          </a:bodyPr>
+          <a:lstStyle/>
+          <a:p>
+            <a:r>
+              <a:rPr sz="1300" b="1" i="0" spc="900">
+                <a:solidFill>
+                  <a:srgbClr val="2F5D62"/>
+                </a:solidFill>
+                <a:latin typeface="Inter"/>
+              </a:rPr>
+              <a:t>YANG BISA KITA PERBAIKI</a:t>
+            </a:r>
+          </a:p>
+        </p:txBody>
+      </p:sp>
+      <p:sp>
+        <p:nvSpPr>
+          <p:cNvPr id="4" name="TextBox 3"/>
+          <p:cNvSpPr txBox="1"/>
+          <p:nvPr/>
+        </p:nvSpPr>
+        <p:spPr>
+          <a:xfrm>
+            <a:off x="548640" y="1051560"/>
+            <a:ext cx="10972800" cy="914400"/>
+          </a:xfrm>
+          <a:prstGeom prst="rect">
+            <a:avLst/>
+          </a:prstGeom>
+          <a:noFill/>
+        </p:spPr>
+        <p:txBody>
+          <a:bodyPr wrap="square" anchor="t" lIns="0" rIns="0" tIns="0" bIns="0">
+            <a:spAutoFit/>
+          </a:bodyPr>
+          <a:lstStyle/>
+          <a:p>
+            <a:r>
+              <a:rPr sz="3600" b="1" i="0">
+                <a:solidFill>
+                  <a:srgbClr val="1F1F1B"/>
+                </a:solidFill>
+                <a:latin typeface="Source Serif 4"/>
+              </a:rPr>
+              <a:t>Indonesia timur butuh </a:t>
+            </a:r>
+            <a:r>
+              <a:rPr sz="3600" b="1" i="0">
+                <a:solidFill>
+                  <a:srgbClr val="8A2D1F"/>
+                </a:solidFill>
+                <a:latin typeface="Source Serif 4"/>
+              </a:rPr>
+              <a:t>lebih banyak mata</a:t>
+            </a:r>
+          </a:p>
+        </p:txBody>
+      </p:sp>
+      <p:sp>
+        <p:nvSpPr>
+          <p:cNvPr id="5" name="TextBox 4"/>
+          <p:cNvSpPr txBox="1"/>
+          <p:nvPr/>
+        </p:nvSpPr>
+        <p:spPr>
+          <a:xfrm>
+            <a:off x="566928" y="2194560"/>
+            <a:ext cx="6400800" cy="4572000"/>
+          </a:xfrm>
+          <a:prstGeom prst="rect">
+            <a:avLst/>
+          </a:prstGeom>
+          <a:noFill/>
+        </p:spPr>
+        <p:txBody>
+          <a:bodyPr wrap="square" anchor="t" lIns="0" rIns="0" tIns="0" bIns="0">
+            <a:spAutoFit/>
+          </a:bodyPr>
+          <a:lstStyle/>
+          <a:p>
+            <a:pPr>
+              <a:lnSpc>
+                <a:spcPct val="120000"/>
+              </a:lnSpc>
+              <a:spcAft>
+                <a:spcPts val="1400"/>
+              </a:spcAft>
+            </a:pPr>
+            <a:r>
+              <a:rPr sz="1400" b="1" i="0">
+                <a:solidFill>
+                  <a:srgbClr val="8A2D1F"/>
+                </a:solidFill>
+                <a:latin typeface="Inter"/>
+              </a:rPr>
+              <a:t>■  </a:t>
+            </a:r>
+            <a:r>
+              <a:rPr sz="1700" b="0" i="0">
+                <a:solidFill>
+                  <a:srgbClr val="1F1F1B"/>
+                </a:solidFill>
+                <a:latin typeface="Inter"/>
+              </a:rPr>
+              <a:t>Kerapatan stasiun di NTT jauh di bawah Jawa → lokasi lebih tak pasti, respons lebih lambat.</a:t>
+            </a:r>
+          </a:p>
+          <a:p>
+            <a:pPr>
+              <a:lnSpc>
+                <a:spcPct val="120000"/>
+              </a:lnSpc>
+              <a:spcAft>
+                <a:spcPts val="1400"/>
+              </a:spcAft>
+            </a:pPr>
+            <a:r>
+              <a:rPr sz="1400" b="1" i="0">
+                <a:solidFill>
+                  <a:srgbClr val="8A2D1F"/>
+                </a:solidFill>
+                <a:latin typeface="Inter"/>
+              </a:rPr>
+              <a:t>■  </a:t>
+            </a:r>
+            <a:r>
+              <a:rPr sz="1700" b="1" i="0">
+                <a:solidFill>
+                  <a:srgbClr val="1F1F1B"/>
+                </a:solidFill>
+                <a:latin typeface="Inter"/>
+              </a:rPr>
+              <a:t>Seismometer biaya rendah &amp; jaringan berbasis komunitas–sekolah</a:t>
+            </a:r>
+            <a:r>
+              <a:rPr sz="1700" b="0" i="0">
+                <a:solidFill>
+                  <a:srgbClr val="1F1F1B"/>
+                </a:solidFill>
+                <a:latin typeface="Inter"/>
+              </a:rPr>
+              <a:t> — merapatkan pemantauan sekaligus membangun kesadaran.</a:t>
+            </a:r>
+          </a:p>
+          <a:p>
+            <a:pPr>
+              <a:lnSpc>
+                <a:spcPct val="120000"/>
+              </a:lnSpc>
+              <a:spcAft>
+                <a:spcPts val="1400"/>
+              </a:spcAft>
+            </a:pPr>
+            <a:r>
+              <a:rPr sz="1400" b="1" i="0">
+                <a:solidFill>
+                  <a:srgbClr val="8A2D1F"/>
+                </a:solidFill>
+                <a:latin typeface="Inter"/>
+              </a:rPr>
+              <a:t>■  </a:t>
+            </a:r>
+            <a:r>
+              <a:rPr sz="1700" b="0" i="0">
+                <a:solidFill>
+                  <a:srgbClr val="1F1F1B"/>
+                </a:solidFill>
+                <a:latin typeface="Inter"/>
+              </a:rPr>
+              <a:t>Penyebaran alat sementara pasca-gempa untuk memantau susulan &amp; memetakan sesar aktif.</a:t>
+            </a:r>
+          </a:p>
+        </p:txBody>
+      </p:sp>
+      <p:sp>
+        <p:nvSpPr>
+          <p:cNvPr id="6" name="Rectangle 5"/>
+          <p:cNvSpPr/>
+          <p:nvPr/>
+        </p:nvSpPr>
+        <p:spPr>
+          <a:xfrm>
+            <a:off x="7315200" y="2194560"/>
+            <a:ext cx="4297680" cy="2377440"/>
+          </a:xfrm>
+          <a:prstGeom prst="rect">
+            <a:avLst/>
+          </a:prstGeom>
+          <a:solidFill>
+            <a:srgbClr val="F1EEE7"/>
+          </a:solidFill>
+          <a:ln>
+            <a:noFill/>
+          </a:ln>
+          <a:effectLst/>
+        </p:spPr>
+        <p:style>
+          <a:lnRef idx="1">
+            <a:schemeClr val="accent1"/>
+          </a:lnRef>
+          <a:fillRef idx="3">
+            <a:schemeClr val="accent1"/>
+          </a:fillRef>
+          <a:effectRef idx="2">
+            <a:schemeClr val="accent1"/>
+          </a:effectRef>
+          <a:fontRef idx="minor">
+            <a:schemeClr val="lt1"/>
+          </a:fontRef>
+        </p:style>
+        <p:txBody>
+          <a:bodyPr rtlCol="0" anchor="ctr"/>
+          <a:lstStyle/>
+          <a:p>
+            <a:pPr algn="ctr"/>
+          </a:p>
+        </p:txBody>
+      </p:sp>
+      <p:sp>
+        <p:nvSpPr>
+          <p:cNvPr id="7" name="Rectangle 6"/>
+          <p:cNvSpPr/>
+          <p:nvPr/>
+        </p:nvSpPr>
+        <p:spPr>
+          <a:xfrm>
+            <a:off x="7315200" y="2194560"/>
+            <a:ext cx="54864" cy="2377440"/>
+          </a:xfrm>
+          <a:prstGeom prst="rect">
+            <a:avLst/>
+          </a:prstGeom>
+          <a:solidFill>
+            <a:srgbClr val="2F5D62"/>
+          </a:solidFill>
+          <a:ln>
+            <a:noFill/>
+          </a:ln>
+          <a:effectLst/>
+        </p:spPr>
+        <p:style>
+          <a:lnRef idx="1">
+            <a:schemeClr val="accent1"/>
+          </a:lnRef>
+          <a:fillRef idx="3">
+            <a:schemeClr val="accent1"/>
+          </a:fillRef>
+          <a:effectRef idx="2">
+            <a:schemeClr val="accent1"/>
+          </a:effectRef>
+          <a:fontRef idx="minor">
+            <a:schemeClr val="lt1"/>
+          </a:fontRef>
+        </p:style>
+        <p:txBody>
+          <a:bodyPr rtlCol="0" anchor="ctr"/>
+          <a:lstStyle/>
+          <a:p>
+            <a:pPr algn="ctr"/>
+          </a:p>
+        </p:txBody>
+      </p:sp>
+      <p:sp>
+        <p:nvSpPr>
+          <p:cNvPr id="8" name="TextBox 7"/>
+          <p:cNvSpPr txBox="1"/>
+          <p:nvPr/>
+        </p:nvSpPr>
+        <p:spPr>
+          <a:xfrm>
+            <a:off x="7571231" y="2395728"/>
+            <a:ext cx="3840480" cy="2011680"/>
+          </a:xfrm>
+          <a:prstGeom prst="rect">
+            <a:avLst/>
+          </a:prstGeom>
+          <a:noFill/>
+        </p:spPr>
+        <p:txBody>
+          <a:bodyPr wrap="square" anchor="t" lIns="0" rIns="0" tIns="0" bIns="0">
+            <a:spAutoFit/>
+          </a:bodyPr>
+          <a:lstStyle/>
+          <a:p>
+            <a:pPr>
+              <a:spcAft>
+                <a:spcPts val="600"/>
+              </a:spcAft>
+            </a:pPr>
+            <a:r>
+              <a:rPr sz="1200" b="1" i="0">
+                <a:solidFill>
+                  <a:srgbClr val="2F5D62"/>
+                </a:solidFill>
+                <a:latin typeface="Inter"/>
+              </a:rPr>
+              <a:t>PENUTUP</a:t>
+            </a:r>
+          </a:p>
+          <a:p>
+            <a:pPr>
+              <a:lnSpc>
+                <a:spcPct val="125000"/>
+              </a:lnSpc>
+            </a:pPr>
+            <a:r>
+              <a:rPr sz="1600" b="0" i="0">
+                <a:solidFill>
+                  <a:srgbClr val="1F1F1B"/>
+                </a:solidFill>
+                <a:latin typeface="Inter"/>
+              </a:rPr>
+              <a:t>Kita tak bisa mencegah gempa. Tapi setiap sensor tambahan dan setiap warga yang tahu harus </a:t>
+            </a:r>
+            <a:r>
+              <a:rPr sz="1600" b="1" i="0">
+                <a:solidFill>
+                  <a:srgbClr val="1F1F1B"/>
+                </a:solidFill>
+                <a:latin typeface="Inter"/>
+              </a:rPr>
+              <a:t>segera lari ke tempat tinggi</a:t>
+            </a:r>
+            <a:r>
+              <a:rPr sz="1600" b="0" i="0">
+                <a:solidFill>
+                  <a:srgbClr val="1F1F1B"/>
+                </a:solidFill>
+                <a:latin typeface="Inter"/>
+              </a:rPr>
+              <a:t> memperbesar peluang kita selamat saat gempa berikutnya datang.</a:t>
+            </a:r>
+          </a:p>
+        </p:txBody>
+      </p:sp>
+      <p:sp>
+        <p:nvSpPr>
+          <p:cNvPr id="9" name="TextBox 8"/>
+          <p:cNvSpPr txBox="1"/>
+          <p:nvPr/>
+        </p:nvSpPr>
+        <p:spPr>
+          <a:xfrm>
+            <a:off x="566928" y="5120640"/>
+            <a:ext cx="10972800" cy="548640"/>
+          </a:xfrm>
+          <a:prstGeom prst="rect">
+            <a:avLst/>
+          </a:prstGeom>
+          <a:noFill/>
+        </p:spPr>
+        <p:txBody>
+          <a:bodyPr wrap="square" anchor="t" lIns="0" rIns="0" tIns="0" bIns="0">
+            <a:spAutoFit/>
+          </a:bodyPr>
+          <a:lstStyle/>
+          <a:p>
+            <a:r>
+              <a:rPr sz="1700" b="1" i="0">
+                <a:solidFill>
+                  <a:srgbClr val="1F1F1B"/>
+                </a:solidFill>
+                <a:latin typeface="Inter"/>
+              </a:rPr>
+              <a:t>Dr.rer.nat. Wiwit Suryanto</a:t>
+            </a:r>
+            <a:r>
+              <a:rPr sz="1700" b="0" i="0">
+                <a:solidFill>
+                  <a:srgbClr val="5F625C"/>
+                </a:solidFill>
+                <a:latin typeface="Inter"/>
+              </a:rPr>
+              <a:t>  ·  Geoscience Research Group, Departemen Fisika, FMIPA UGM  ·  Terima kasih.</a:t>
+            </a:r>
+          </a:p>
+        </p:txBody>
+      </p:sp>
+      <p:sp>
+        <p:nvSpPr>
+          <p:cNvPr id="10" name="TextBox 9"/>
+          <p:cNvSpPr txBox="1"/>
+          <p:nvPr/>
+        </p:nvSpPr>
+        <p:spPr>
+          <a:xfrm>
+            <a:off x="566928" y="6355080"/>
+            <a:ext cx="8229600" cy="365760"/>
+          </a:xfrm>
+          <a:prstGeom prst="rect">
+            <a:avLst/>
+          </a:prstGeom>
+          <a:noFill/>
+        </p:spPr>
+        <p:txBody>
+          <a:bodyPr wrap="square" anchor="t" lIns="0" rIns="0" tIns="0" bIns="0">
+            <a:spAutoFit/>
+          </a:bodyPr>
+          <a:lstStyle/>
+          <a:p>
+            <a:r>
+              <a:rPr sz="1050" b="0" i="0">
+                <a:solidFill>
+                  <a:srgbClr val="5F625C"/>
+                </a:solidFill>
+                <a:latin typeface="Inter"/>
+              </a:rPr>
+              <a:t>Diskusi Publik PSBA UGM — Respons Tanggap Darurat Gempa NTT</a:t>
+            </a:r>
+          </a:p>
+        </p:txBody>
+      </p:sp>
+      <p:sp>
+        <p:nvSpPr>
+          <p:cNvPr id="11" name="TextBox 10"/>
+          <p:cNvSpPr txBox="1"/>
+          <p:nvPr/>
+        </p:nvSpPr>
+        <p:spPr>
+          <a:xfrm>
+            <a:off x="10789920" y="6355080"/>
+            <a:ext cx="914400" cy="365760"/>
+          </a:xfrm>
+          <a:prstGeom prst="rect">
+            <a:avLst/>
+          </a:prstGeom>
+          <a:noFill/>
+        </p:spPr>
+        <p:txBody>
+          <a:bodyPr wrap="square" anchor="t" lIns="0" rIns="0" tIns="0" bIns="0">
+            <a:spAutoFit/>
+          </a:bodyPr>
+          <a:lstStyle/>
+          <a:p>
+            <a:pPr algn="r"/>
+            <a:r>
+              <a:rPr sz="1050" b="0" i="0">
+                <a:solidFill>
+                  <a:srgbClr val="5F625C"/>
+                </a:solidFill>
+                <a:latin typeface="Inter"/>
+              </a:rPr>
+              <a:t>10 / 10</a:t>
             </a:r>
           </a:p>
         </p:txBody>
@@ -3689,7 +4218,7 @@
                 </a:solidFill>
                 <a:latin typeface="Inter"/>
               </a:rPr>
-              <a:t>2 / 9</a:t>
+              <a:t>2 / 10</a:t>
             </a:r>
           </a:p>
         </p:txBody>
@@ -4086,7 +4615,7 @@
                 </a:solidFill>
                 <a:latin typeface="Inter"/>
               </a:rPr>
-              <a:t>3 / 9</a:t>
+              <a:t>3 / 10</a:t>
             </a:r>
           </a:p>
         </p:txBody>
@@ -5219,7 +5748,7 @@
                 </a:solidFill>
                 <a:latin typeface="Inter"/>
               </a:rPr>
-              <a:t>4 / 9</a:t>
+              <a:t>4 / 10</a:t>
             </a:r>
           </a:p>
         </p:txBody>
@@ -5957,7 +6486,7 @@
                 </a:solidFill>
                 <a:latin typeface="Inter"/>
               </a:rPr>
-              <a:t>5 / 9</a:t>
+              <a:t>5 / 10</a:t>
             </a:r>
           </a:p>
         </p:txBody>
@@ -6053,7 +6582,7 @@
                 </a:solidFill>
                 <a:latin typeface="Inter"/>
               </a:rPr>
-              <a:t>72 JAM PERTAMA</a:t>
+              <a:t>SEBELUM ERA SEISMOGRAF</a:t>
             </a:r>
           </a:p>
         </p:txBody>
@@ -6081,13 +6610,13 @@
           <a:lstStyle/>
           <a:p>
             <a:r>
-              <a:rPr sz="2600" b="1" i="0">
+              <a:rPr sz="2500" b="1" i="0">
                 <a:solidFill>
                   <a:srgbClr val="1F1F1B"/>
                 </a:solidFill>
                 <a:latin typeface="Source Serif 4"/>
               </a:rPr>
-              <a:t>Apa yang dikerjakan seismologi saat tanggap darurat</a:t>
+              <a:t>Sejarah sudah mencatatnya — jauh sebelum kita bisa mengukurnya</a:t>
             </a:r>
           </a:p>
         </p:txBody>
@@ -6101,7 +6630,7 @@
         <p:spPr>
           <a:xfrm>
             <a:off x="566928" y="1783080"/>
-            <a:ext cx="10972800" cy="4572000"/>
+            <a:ext cx="1097280" cy="548640"/>
           </a:xfrm>
           <a:prstGeom prst="rect">
             <a:avLst/>
@@ -6114,165 +6643,532 @@
           </a:bodyPr>
           <a:lstStyle/>
           <a:p>
+            <a:r>
+              <a:rPr sz="2300" b="1" i="0">
+                <a:solidFill>
+                  <a:srgbClr val="8A2D1F"/>
+                </a:solidFill>
+                <a:latin typeface="Inter"/>
+              </a:rPr>
+              <a:t>1648</a:t>
+            </a:r>
+          </a:p>
+        </p:txBody>
+      </p:sp>
+      <p:sp>
+        <p:nvSpPr>
+          <p:cNvPr id="6" name="TextBox 5"/>
+          <p:cNvSpPr txBox="1"/>
+          <p:nvPr/>
+        </p:nvSpPr>
+        <p:spPr>
+          <a:xfrm>
+            <a:off x="1783080" y="1801368"/>
+            <a:ext cx="4754880" cy="868680"/>
+          </a:xfrm>
+          <a:prstGeom prst="rect">
+            <a:avLst/>
+          </a:prstGeom>
+          <a:noFill/>
+        </p:spPr>
+        <p:txBody>
+          <a:bodyPr wrap="square" anchor="t" lIns="0" rIns="0" tIns="0" bIns="0">
+            <a:spAutoFit/>
+          </a:bodyPr>
+          <a:lstStyle/>
+          <a:p>
             <a:pPr>
               <a:lnSpc>
-                <a:spcPct val="120000"/>
+                <a:spcPct val="112000"/>
               </a:lnSpc>
-              <a:spcAft>
-                <a:spcPts val="1200"/>
-              </a:spcAft>
             </a:pPr>
             <a:r>
-              <a:rPr sz="1400" b="1" i="0">
+              <a:rPr sz="1450" b="1" i="0">
+                <a:solidFill>
+                  <a:srgbClr val="1F1F1B"/>
+                </a:solidFill>
+                <a:latin typeface="Inter"/>
+              </a:rPr>
+              <a:t>Solor–Larantuka</a:t>
+            </a:r>
+            <a:r>
+              <a:rPr sz="1450" b="0" i="0">
+                <a:solidFill>
+                  <a:srgbClr val="1F1F1B"/>
+                </a:solidFill>
+                <a:latin typeface="Inter"/>
+              </a:rPr>
+              <a:t> — rangkaian gempa merusak paling awal tercatat di NTT; tembok Benteng Henricus runtuh.</a:t>
+            </a:r>
+          </a:p>
+        </p:txBody>
+      </p:sp>
+      <p:sp>
+        <p:nvSpPr>
+          <p:cNvPr id="7" name="Rectangle 6"/>
+          <p:cNvSpPr/>
+          <p:nvPr/>
+        </p:nvSpPr>
+        <p:spPr>
+          <a:xfrm>
+            <a:off x="566928" y="2606040"/>
+            <a:ext cx="6172200" cy="12801"/>
+          </a:xfrm>
+          <a:prstGeom prst="rect">
+            <a:avLst/>
+          </a:prstGeom>
+          <a:solidFill>
+            <a:srgbClr val="D8D2C5"/>
+          </a:solidFill>
+          <a:ln>
+            <a:noFill/>
+          </a:ln>
+          <a:effectLst/>
+        </p:spPr>
+        <p:style>
+          <a:lnRef idx="1">
+            <a:schemeClr val="accent1"/>
+          </a:lnRef>
+          <a:fillRef idx="3">
+            <a:schemeClr val="accent1"/>
+          </a:fillRef>
+          <a:effectRef idx="2">
+            <a:schemeClr val="accent1"/>
+          </a:effectRef>
+          <a:fontRef idx="minor">
+            <a:schemeClr val="lt1"/>
+          </a:fontRef>
+        </p:style>
+        <p:txBody>
+          <a:bodyPr rtlCol="0" anchor="ctr"/>
+          <a:lstStyle/>
+          <a:p>
+            <a:pPr algn="ctr"/>
+          </a:p>
+        </p:txBody>
+      </p:sp>
+      <p:sp>
+        <p:nvSpPr>
+          <p:cNvPr id="8" name="TextBox 7"/>
+          <p:cNvSpPr txBox="1"/>
+          <p:nvPr/>
+        </p:nvSpPr>
+        <p:spPr>
+          <a:xfrm>
+            <a:off x="566928" y="2697480"/>
+            <a:ext cx="1097280" cy="548640"/>
+          </a:xfrm>
+          <a:prstGeom prst="rect">
+            <a:avLst/>
+          </a:prstGeom>
+          <a:noFill/>
+        </p:spPr>
+        <p:txBody>
+          <a:bodyPr wrap="square" anchor="t" lIns="0" rIns="0" tIns="0" bIns="0">
+            <a:spAutoFit/>
+          </a:bodyPr>
+          <a:lstStyle/>
+          <a:p>
+            <a:r>
+              <a:rPr sz="2300" b="1" i="0">
                 <a:solidFill>
                   <a:srgbClr val="8A2D1F"/>
                 </a:solidFill>
                 <a:latin typeface="Inter"/>
               </a:rPr>
-              <a:t>■  </a:t>
-            </a:r>
-            <a:r>
-              <a:rPr sz="1700" b="1" i="0">
-                <a:solidFill>
-                  <a:srgbClr val="1F1F1B"/>
-                </a:solidFill>
-                <a:latin typeface="Inter"/>
-              </a:rPr>
-              <a:t>Menit pertama — membaca “telegram” bumi. </a:t>
-            </a:r>
-            <a:r>
-              <a:rPr sz="1700" b="0" i="0">
-                <a:solidFill>
-                  <a:srgbClr val="1F1F1B"/>
-                </a:solidFill>
-                <a:latin typeface="Inter"/>
-              </a:rPr>
-              <a:t>Gelombang P tiba lebih dulu, membawa lokasi, kedalaman, magnitudo, dan mekanisme dalam hitungan menit.</a:t>
-            </a:r>
-          </a:p>
+              <a:t>1837</a:t>
+            </a:r>
+          </a:p>
+        </p:txBody>
+      </p:sp>
+      <p:sp>
+        <p:nvSpPr>
+          <p:cNvPr id="9" name="TextBox 8"/>
+          <p:cNvSpPr txBox="1"/>
+          <p:nvPr/>
+        </p:nvSpPr>
+        <p:spPr>
+          <a:xfrm>
+            <a:off x="1783080" y="2715768"/>
+            <a:ext cx="4754880" cy="868680"/>
+          </a:xfrm>
+          <a:prstGeom prst="rect">
+            <a:avLst/>
+          </a:prstGeom>
+          <a:noFill/>
+        </p:spPr>
+        <p:txBody>
+          <a:bodyPr wrap="square" anchor="t" lIns="0" rIns="0" tIns="0" bIns="0">
+            <a:spAutoFit/>
+          </a:bodyPr>
+          <a:lstStyle/>
           <a:p>
             <a:pPr>
               <a:lnSpc>
-                <a:spcPct val="120000"/>
+                <a:spcPct val="112000"/>
               </a:lnSpc>
-              <a:spcAft>
-                <a:spcPts val="1200"/>
-              </a:spcAft>
             </a:pPr>
             <a:r>
-              <a:rPr sz="1400" b="1" i="0">
+              <a:rPr sz="1450" b="1" i="0">
+                <a:solidFill>
+                  <a:srgbClr val="1F1F1B"/>
+                </a:solidFill>
+                <a:latin typeface="Inter"/>
+              </a:rPr>
+              <a:t>Laut utara Flores</a:t>
+            </a:r>
+            <a:r>
+              <a:rPr sz="1450" b="0" i="0">
+                <a:solidFill>
+                  <a:srgbClr val="1F1F1B"/>
+                </a:solidFill>
+                <a:latin typeface="Inter"/>
+              </a:rPr>
+              <a:t> — gempa laut (seaquake) kuat dirasakan dari perahu.</a:t>
+            </a:r>
+          </a:p>
+        </p:txBody>
+      </p:sp>
+      <p:sp>
+        <p:nvSpPr>
+          <p:cNvPr id="10" name="Rectangle 9"/>
+          <p:cNvSpPr/>
+          <p:nvPr/>
+        </p:nvSpPr>
+        <p:spPr>
+          <a:xfrm>
+            <a:off x="566928" y="3520440"/>
+            <a:ext cx="6172200" cy="12801"/>
+          </a:xfrm>
+          <a:prstGeom prst="rect">
+            <a:avLst/>
+          </a:prstGeom>
+          <a:solidFill>
+            <a:srgbClr val="D8D2C5"/>
+          </a:solidFill>
+          <a:ln>
+            <a:noFill/>
+          </a:ln>
+          <a:effectLst/>
+        </p:spPr>
+        <p:style>
+          <a:lnRef idx="1">
+            <a:schemeClr val="accent1"/>
+          </a:lnRef>
+          <a:fillRef idx="3">
+            <a:schemeClr val="accent1"/>
+          </a:fillRef>
+          <a:effectRef idx="2">
+            <a:schemeClr val="accent1"/>
+          </a:effectRef>
+          <a:fontRef idx="minor">
+            <a:schemeClr val="lt1"/>
+          </a:fontRef>
+        </p:style>
+        <p:txBody>
+          <a:bodyPr rtlCol="0" anchor="ctr"/>
+          <a:lstStyle/>
+          <a:p>
+            <a:pPr algn="ctr"/>
+          </a:p>
+        </p:txBody>
+      </p:sp>
+      <p:sp>
+        <p:nvSpPr>
+          <p:cNvPr id="11" name="TextBox 10"/>
+          <p:cNvSpPr txBox="1"/>
+          <p:nvPr/>
+        </p:nvSpPr>
+        <p:spPr>
+          <a:xfrm>
+            <a:off x="566928" y="3611880"/>
+            <a:ext cx="1097280" cy="548640"/>
+          </a:xfrm>
+          <a:prstGeom prst="rect">
+            <a:avLst/>
+          </a:prstGeom>
+          <a:noFill/>
+        </p:spPr>
+        <p:txBody>
+          <a:bodyPr wrap="square" anchor="t" lIns="0" rIns="0" tIns="0" bIns="0">
+            <a:spAutoFit/>
+          </a:bodyPr>
+          <a:lstStyle/>
+          <a:p>
+            <a:r>
+              <a:rPr sz="2300" b="1" i="0">
                 <a:solidFill>
                   <a:srgbClr val="8A2D1F"/>
                 </a:solidFill>
                 <a:latin typeface="Inter"/>
               </a:rPr>
-              <a:t>■  </a:t>
-            </a:r>
-            <a:r>
-              <a:rPr sz="1700" b="1" i="0">
-                <a:solidFill>
-                  <a:srgbClr val="1F1F1B"/>
-                </a:solidFill>
-                <a:latin typeface="Inter"/>
-              </a:rPr>
-              <a:t>ShakeMap. </a:t>
-            </a:r>
-            <a:r>
-              <a:rPr sz="1700" b="0" i="0">
-                <a:solidFill>
-                  <a:srgbClr val="1F1F1B"/>
-                </a:solidFill>
-                <a:latin typeface="Inter"/>
-              </a:rPr>
-              <a:t>Dari satu sumber, kita petakan sebaran guncangan — menebak di mana kerusakan terparah sebelum laporan masuk, untuk mengarahkan SAR.</a:t>
-            </a:r>
-          </a:p>
+              <a:t>1855</a:t>
+            </a:r>
+          </a:p>
+        </p:txBody>
+      </p:sp>
+      <p:sp>
+        <p:nvSpPr>
+          <p:cNvPr id="12" name="TextBox 11"/>
+          <p:cNvSpPr txBox="1"/>
+          <p:nvPr/>
+        </p:nvSpPr>
+        <p:spPr>
+          <a:xfrm>
+            <a:off x="1783080" y="3630168"/>
+            <a:ext cx="4754880" cy="868680"/>
+          </a:xfrm>
+          <a:prstGeom prst="rect">
+            <a:avLst/>
+          </a:prstGeom>
+          <a:noFill/>
+        </p:spPr>
+        <p:txBody>
+          <a:bodyPr wrap="square" anchor="t" lIns="0" rIns="0" tIns="0" bIns="0">
+            <a:spAutoFit/>
+          </a:bodyPr>
+          <a:lstStyle/>
           <a:p>
             <a:pPr>
               <a:lnSpc>
-                <a:spcPct val="120000"/>
+                <a:spcPct val="112000"/>
               </a:lnSpc>
-              <a:spcAft>
-                <a:spcPts val="1200"/>
-              </a:spcAft>
             </a:pPr>
             <a:r>
-              <a:rPr sz="1400" b="1" i="0">
+              <a:rPr sz="1450" b="1" i="0">
+                <a:solidFill>
+                  <a:srgbClr val="1F1F1B"/>
+                </a:solidFill>
+                <a:latin typeface="Inter"/>
+              </a:rPr>
+              <a:t>Nanga Rama, Manggarai</a:t>
+            </a:r>
+            <a:r>
+              <a:rPr sz="1450" b="0" i="0">
+                <a:solidFill>
+                  <a:srgbClr val="1F1F1B"/>
+                </a:solidFill>
+                <a:latin typeface="Inter"/>
+              </a:rPr>
+              <a:t> — gelombang besar menerjang teluk (kandidat tsunami).</a:t>
+            </a:r>
+          </a:p>
+        </p:txBody>
+      </p:sp>
+      <p:sp>
+        <p:nvSpPr>
+          <p:cNvPr id="13" name="Rectangle 12"/>
+          <p:cNvSpPr/>
+          <p:nvPr/>
+        </p:nvSpPr>
+        <p:spPr>
+          <a:xfrm>
+            <a:off x="566928" y="4434840"/>
+            <a:ext cx="6172200" cy="12801"/>
+          </a:xfrm>
+          <a:prstGeom prst="rect">
+            <a:avLst/>
+          </a:prstGeom>
+          <a:solidFill>
+            <a:srgbClr val="D8D2C5"/>
+          </a:solidFill>
+          <a:ln>
+            <a:noFill/>
+          </a:ln>
+          <a:effectLst/>
+        </p:spPr>
+        <p:style>
+          <a:lnRef idx="1">
+            <a:schemeClr val="accent1"/>
+          </a:lnRef>
+          <a:fillRef idx="3">
+            <a:schemeClr val="accent1"/>
+          </a:fillRef>
+          <a:effectRef idx="2">
+            <a:schemeClr val="accent1"/>
+          </a:effectRef>
+          <a:fontRef idx="minor">
+            <a:schemeClr val="lt1"/>
+          </a:fontRef>
+        </p:style>
+        <p:txBody>
+          <a:bodyPr rtlCol="0" anchor="ctr"/>
+          <a:lstStyle/>
+          <a:p>
+            <a:pPr algn="ctr"/>
+          </a:p>
+        </p:txBody>
+      </p:sp>
+      <p:sp>
+        <p:nvSpPr>
+          <p:cNvPr id="14" name="TextBox 13"/>
+          <p:cNvSpPr txBox="1"/>
+          <p:nvPr/>
+        </p:nvSpPr>
+        <p:spPr>
+          <a:xfrm>
+            <a:off x="566928" y="4526280"/>
+            <a:ext cx="1097280" cy="548640"/>
+          </a:xfrm>
+          <a:prstGeom prst="rect">
+            <a:avLst/>
+          </a:prstGeom>
+          <a:noFill/>
+        </p:spPr>
+        <p:txBody>
+          <a:bodyPr wrap="square" anchor="t" lIns="0" rIns="0" tIns="0" bIns="0">
+            <a:spAutoFit/>
+          </a:bodyPr>
+          <a:lstStyle/>
+          <a:p>
+            <a:r>
+              <a:rPr sz="2300" b="1" i="0">
                 <a:solidFill>
                   <a:srgbClr val="8A2D1F"/>
                 </a:solidFill>
                 <a:latin typeface="Inter"/>
               </a:rPr>
-              <a:t>■  </a:t>
-            </a:r>
-            <a:r>
-              <a:rPr sz="1700" b="1" i="0">
-                <a:solidFill>
-                  <a:srgbClr val="1F1F1B"/>
-                </a:solidFill>
-                <a:latin typeface="Inter"/>
-              </a:rPr>
-              <a:t>Peringatan tsunami. </a:t>
-            </a:r>
-            <a:r>
-              <a:rPr sz="1700" b="0" i="0">
-                <a:solidFill>
-                  <a:srgbClr val="1F1F1B"/>
-                </a:solidFill>
-                <a:latin typeface="Inter"/>
-              </a:rPr>
-              <a:t>Keputusan besar diambil di menit-menit awal (lihat: 2 menit 16 detik).</a:t>
-            </a:r>
-          </a:p>
+              <a:t>1868</a:t>
+            </a:r>
+          </a:p>
+        </p:txBody>
+      </p:sp>
+      <p:sp>
+        <p:nvSpPr>
+          <p:cNvPr id="15" name="TextBox 14"/>
+          <p:cNvSpPr txBox="1"/>
+          <p:nvPr/>
+        </p:nvSpPr>
+        <p:spPr>
+          <a:xfrm>
+            <a:off x="1783080" y="4544568"/>
+            <a:ext cx="4754880" cy="868680"/>
+          </a:xfrm>
+          <a:prstGeom prst="rect">
+            <a:avLst/>
+          </a:prstGeom>
+          <a:noFill/>
+        </p:spPr>
+        <p:txBody>
+          <a:bodyPr wrap="square" anchor="t" lIns="0" rIns="0" tIns="0" bIns="0">
+            <a:spAutoFit/>
+          </a:bodyPr>
+          <a:lstStyle/>
           <a:p>
             <a:pPr>
               <a:lnSpc>
-                <a:spcPct val="120000"/>
+                <a:spcPct val="112000"/>
               </a:lnSpc>
-              <a:spcAft>
-                <a:spcPts val="1200"/>
-              </a:spcAft>
             </a:pPr>
             <a:r>
-              <a:rPr sz="1400" b="1" i="0">
-                <a:solidFill>
-                  <a:srgbClr val="8A2D1F"/>
-                </a:solidFill>
-                <a:latin typeface="Inter"/>
-              </a:rPr>
-              <a:t>■  </a:t>
-            </a:r>
-            <a:r>
-              <a:rPr sz="1700" b="1" i="0">
+              <a:rPr sz="1450" b="1" i="0">
                 <a:solidFill>
                   <a:srgbClr val="1F1F1B"/>
                 </a:solidFill>
                 <a:latin typeface="Inter"/>
               </a:rPr>
-              <a:t>Prakiraan gempa susulan. </a:t>
-            </a:r>
-            <a:r>
-              <a:rPr sz="1700" b="0" i="0">
+              <a:t>Ambugaga, Ende</a:t>
+            </a:r>
+            <a:r>
+              <a:rPr sz="1450" b="0" i="0">
                 <a:solidFill>
                   <a:srgbClr val="1F1F1B"/>
                 </a:solidFill>
                 <a:latin typeface="Inter"/>
               </a:rPr>
-              <a:t>Melindungi penyintas dan relawan yang masuk ke bangunan retak.</a:t>
-            </a:r>
-          </a:p>
-        </p:txBody>
-      </p:sp>
-      <p:sp>
-        <p:nvSpPr>
-          <p:cNvPr id="6" name="Rectangle 5"/>
+              <a:t> — guncangan sangat keras ±2 menit di Flores tengah.</a:t>
+            </a:r>
+          </a:p>
+        </p:txBody>
+      </p:sp>
+      <p:sp>
+        <p:nvSpPr>
+          <p:cNvPr id="16" name="Rectangle 15"/>
           <p:cNvSpPr/>
           <p:nvPr/>
         </p:nvSpPr>
         <p:spPr>
           <a:xfrm>
-            <a:off x="566928" y="4572000"/>
-            <a:ext cx="11064240" cy="1371600"/>
+            <a:off x="566928" y="5349240"/>
+            <a:ext cx="6172200" cy="12801"/>
+          </a:xfrm>
+          <a:prstGeom prst="rect">
+            <a:avLst/>
+          </a:prstGeom>
+          <a:solidFill>
+            <a:srgbClr val="D8D2C5"/>
+          </a:solidFill>
+          <a:ln>
+            <a:noFill/>
+          </a:ln>
+          <a:effectLst/>
+        </p:spPr>
+        <p:style>
+          <a:lnRef idx="1">
+            <a:schemeClr val="accent1"/>
+          </a:lnRef>
+          <a:fillRef idx="3">
+            <a:schemeClr val="accent1"/>
+          </a:fillRef>
+          <a:effectRef idx="2">
+            <a:schemeClr val="accent1"/>
+          </a:effectRef>
+          <a:fontRef idx="minor">
+            <a:schemeClr val="lt1"/>
+          </a:fontRef>
+        </p:style>
+        <p:txBody>
+          <a:bodyPr rtlCol="0" anchor="ctr"/>
+          <a:lstStyle/>
+          <a:p>
+            <a:pPr algn="ctr"/>
+          </a:p>
+        </p:txBody>
+      </p:sp>
+      <p:sp>
+        <p:nvSpPr>
+          <p:cNvPr id="17" name="TextBox 16"/>
+          <p:cNvSpPr txBox="1"/>
+          <p:nvPr/>
+        </p:nvSpPr>
+        <p:spPr>
+          <a:xfrm>
+            <a:off x="566928" y="5458968"/>
+            <a:ext cx="6217920" cy="457200"/>
+          </a:xfrm>
+          <a:prstGeom prst="rect">
+            <a:avLst/>
+          </a:prstGeom>
+          <a:noFill/>
+        </p:spPr>
+        <p:txBody>
+          <a:bodyPr wrap="square" anchor="t" lIns="0" rIns="0" tIns="0" bIns="0">
+            <a:spAutoFit/>
+          </a:bodyPr>
+          <a:lstStyle/>
+          <a:p>
+            <a:r>
+              <a:rPr sz="1100" b="0" i="1">
+                <a:solidFill>
+                  <a:srgbClr val="5F625C"/>
+                </a:solidFill>
+                <a:latin typeface="Inter"/>
+              </a:rPr>
+              <a:t>Catatan makroseismik historis — belum dapat diberi magnitudo atau dipastikan dari sesar yang sama.</a:t>
+            </a:r>
+          </a:p>
+        </p:txBody>
+      </p:sp>
+      <p:sp>
+        <p:nvSpPr>
+          <p:cNvPr id="18" name="Rectangle 17"/>
+          <p:cNvSpPr/>
+          <p:nvPr/>
+        </p:nvSpPr>
+        <p:spPr>
+          <a:xfrm>
+            <a:off x="7040880" y="2011680"/>
+            <a:ext cx="4572000" cy="2926080"/>
           </a:xfrm>
           <a:prstGeom prst="rect">
             <a:avLst/>
@@ -6309,14 +7205,14 @@
       </p:sp>
       <p:sp>
         <p:nvSpPr>
-          <p:cNvPr id="7" name="Rectangle 6"/>
+          <p:cNvPr id="19" name="Rectangle 18"/>
           <p:cNvSpPr/>
           <p:nvPr/>
         </p:nvSpPr>
         <p:spPr>
           <a:xfrm>
-            <a:off x="566928" y="4572000"/>
-            <a:ext cx="54864" cy="1371600"/>
+            <a:off x="7040880" y="2011680"/>
+            <a:ext cx="54864" cy="2926080"/>
           </a:xfrm>
           <a:prstGeom prst="rect">
             <a:avLst/>
@@ -6353,14 +7249,14 @@
       </p:sp>
       <p:sp>
         <p:nvSpPr>
-          <p:cNvPr id="8" name="TextBox 7"/>
+          <p:cNvPr id="20" name="TextBox 19"/>
           <p:cNvSpPr txBox="1"/>
           <p:nvPr/>
         </p:nvSpPr>
         <p:spPr>
           <a:xfrm>
-            <a:off x="822960" y="4773168"/>
-            <a:ext cx="10607040" cy="1005840"/>
+            <a:off x="7296912" y="2212848"/>
+            <a:ext cx="4114800" cy="2560320"/>
           </a:xfrm>
           <a:prstGeom prst="rect">
             <a:avLst/>
@@ -6385,7 +7281,7 @@
                 </a:solidFill>
                 <a:latin typeface="Inter"/>
               </a:rPr>
-              <a:t>KECEPATAN VS KETELITIAN</a:t>
+              <a:t>BENANG MERAH</a:t>
             </a:r>
           </a:p>
           <a:p>
@@ -6401,7 +7297,7 @@
                 </a:solidFill>
                 <a:latin typeface="Inter"/>
               </a:rPr>
-              <a:t>Mw 7,7 (USGS) vs 7,61 (GFZ); 10 km vs 25 km. Magnitudo </a:t>
+              <a:t>Katalog Arthur Wichmann (hingga 1877) mencatat gempa, gempa laut, dan tsunami di Flores–NTT jauh sebelum ada seismograf. </a:t>
             </a:r>
             <a:r>
               <a:rPr sz="1600" b="1" i="0">
@@ -6410,7 +7306,7 @@
                 </a:solidFill>
                 <a:latin typeface="Inter"/>
               </a:rPr>
-              <a:t>direvisi</a:t>
+              <a:t>Sejarah sudah memperingatkan; 2026 menegaskannya.</a:t>
             </a:r>
             <a:r>
               <a:rPr sz="1600" b="0" i="0">
@@ -6419,14 +7315,14 @@
                 </a:solidFill>
                 <a:latin typeface="Inter"/>
               </a:rPr>
-              <a:t> seiring data masuk — ini normal, bukan kesalahan. Publik perlu memahaminya.</a:t>
-            </a:r>
-          </a:p>
-        </p:txBody>
-      </p:sp>
-      <p:sp>
-        <p:nvSpPr>
-          <p:cNvPr id="9" name="TextBox 8"/>
+              <a:t> Ke depan, kesiapsiagaan bukan pilihan.</a:t>
+            </a:r>
+          </a:p>
+        </p:txBody>
+      </p:sp>
+      <p:sp>
+        <p:nvSpPr>
+          <p:cNvPr id="21" name="TextBox 20"/>
           <p:cNvSpPr txBox="1"/>
           <p:nvPr/>
         </p:nvSpPr>
@@ -6453,14 +7349,14 @@
                 </a:solidFill>
                 <a:latin typeface="Inter"/>
               </a:rPr>
-              <a:t>Peran geofisika dalam rantai tanggap darurat</a:t>
-            </a:r>
-          </a:p>
-        </p:txBody>
-      </p:sp>
-      <p:sp>
-        <p:nvSpPr>
-          <p:cNvPr id="10" name="TextBox 9"/>
+              <a:t>Sumber: A. Wichmann, katalog gempa Kepulauan Hindia (hingga 1877)</a:t>
+            </a:r>
+          </a:p>
+        </p:txBody>
+      </p:sp>
+      <p:sp>
+        <p:nvSpPr>
+          <p:cNvPr id="22" name="TextBox 21"/>
           <p:cNvSpPr txBox="1"/>
           <p:nvPr/>
         </p:nvSpPr>
@@ -6488,7 +7384,7 @@
                 </a:solidFill>
                 <a:latin typeface="Inter"/>
               </a:rPr>
-              <a:t>6 / 9</a:t>
+              <a:t>6 / 10</a:t>
             </a:r>
           </a:p>
         </p:txBody>
@@ -6580,11 +7476,11 @@
             <a:r>
               <a:rPr sz="1300" b="1" i="0" spc="900">
                 <a:solidFill>
-                  <a:srgbClr val="8A2D1F"/>
-                </a:solidFill>
-                <a:latin typeface="Inter"/>
-              </a:rPr>
-              <a:t>REKAMAN LANGSUNG — GE.MMRI, MAUMERE</a:t>
+                  <a:srgbClr val="2F5D62"/>
+                </a:solidFill>
+                <a:latin typeface="Inter"/>
+              </a:rPr>
+              <a:t>72 JAM PERTAMA</a:t>
             </a:r>
           </a:p>
         </p:txBody>
@@ -6598,7 +7494,7 @@
         <p:spPr>
           <a:xfrm>
             <a:off x="548640" y="868680"/>
-            <a:ext cx="11155680" cy="914400"/>
+            <a:ext cx="10972800" cy="640080"/>
           </a:xfrm>
           <a:prstGeom prst="rect">
             <a:avLst/>
@@ -6611,227 +7507,28 @@
           </a:bodyPr>
           <a:lstStyle/>
           <a:p>
-            <a:pPr>
-              <a:lnSpc>
-                <a:spcPct val="105000"/>
-              </a:lnSpc>
-            </a:pPr>
-            <a:r>
-              <a:rPr sz="2500" b="1" i="0">
+            <a:r>
+              <a:rPr sz="2600" b="1" i="0">
                 <a:solidFill>
                   <a:srgbClr val="1F1F1B"/>
                 </a:solidFill>
                 <a:latin typeface="Source Serif 4"/>
               </a:rPr>
-              <a:t>Guncangan yang meruntuhkan Pelabuhan Maumere, terekam ±104 km dari sumber</a:t>
-            </a:r>
-          </a:p>
-        </p:txBody>
-      </p:sp>
-      <p:sp>
-        <p:nvSpPr>
-          <p:cNvPr id="5" name="Rectangle 4"/>
-          <p:cNvSpPr/>
-          <p:nvPr/>
-        </p:nvSpPr>
-        <p:spPr>
-          <a:xfrm>
-            <a:off x="548640" y="1828800"/>
-            <a:ext cx="6720840" cy="4114800"/>
-          </a:xfrm>
-          <a:prstGeom prst="rect">
-            <a:avLst/>
-          </a:prstGeom>
-          <a:solidFill>
-            <a:srgbClr val="FFFFFF"/>
-          </a:solidFill>
-          <a:ln w="12700">
-            <a:solidFill>
-              <a:srgbClr val="D8D2C5"/>
-            </a:solidFill>
-          </a:ln>
-          <a:effectLst/>
-        </p:spPr>
-        <p:style>
-          <a:lnRef idx="1">
-            <a:schemeClr val="accent1"/>
-          </a:lnRef>
-          <a:fillRef idx="3">
-            <a:schemeClr val="accent1"/>
-          </a:fillRef>
-          <a:effectRef idx="2">
-            <a:schemeClr val="accent1"/>
-          </a:effectRef>
-          <a:fontRef idx="minor">
-            <a:schemeClr val="lt1"/>
-          </a:fontRef>
-        </p:style>
-        <p:txBody>
-          <a:bodyPr rtlCol="0" anchor="ctr"/>
-          <a:lstStyle/>
-          <a:p>
-            <a:pPr algn="ctr"/>
-          </a:p>
-        </p:txBody>
-      </p:sp>
-      <p:pic>
-        <p:nvPicPr>
-          <p:cNvPr id="6" name="Picture 5" descr="waveform_mmri_flores2026.png"/>
-          <p:cNvPicPr>
-            <a:picLocks noChangeAspect="1"/>
-          </p:cNvPicPr>
-          <p:nvPr/>
-        </p:nvPicPr>
-        <p:blipFill>
-          <a:blip r:embed="rId2"/>
-          <a:stretch>
-            <a:fillRect/>
-          </a:stretch>
-        </p:blipFill>
-        <p:spPr>
-          <a:xfrm>
-            <a:off x="658368" y="1938528"/>
-            <a:ext cx="6492240" cy="5553138"/>
-          </a:xfrm>
-          <a:prstGeom prst="rect">
-            <a:avLst/>
-          </a:prstGeom>
-        </p:spPr>
-      </p:pic>
-      <p:sp>
-        <p:nvSpPr>
-          <p:cNvPr id="7" name="TextBox 6"/>
+              <a:t>Apa yang dikerjakan seismologi saat tanggap darurat</a:t>
+            </a:r>
+          </a:p>
+        </p:txBody>
+      </p:sp>
+      <p:sp>
+        <p:nvSpPr>
+          <p:cNvPr id="5" name="TextBox 4"/>
           <p:cNvSpPr txBox="1"/>
           <p:nvPr/>
         </p:nvSpPr>
         <p:spPr>
           <a:xfrm>
-            <a:off x="658368" y="5532120"/>
-            <a:ext cx="6492240" cy="365760"/>
-          </a:xfrm>
-          <a:prstGeom prst="rect">
-            <a:avLst/>
-          </a:prstGeom>
-          <a:noFill/>
-        </p:spPr>
-        <p:txBody>
-          <a:bodyPr wrap="square" anchor="t" lIns="0" rIns="0" tIns="0" bIns="0">
-            <a:spAutoFit/>
-          </a:bodyPr>
-          <a:lstStyle/>
-          <a:p>
-            <a:r>
-              <a:rPr sz="1200" b="0" i="0">
-                <a:solidFill>
-                  <a:srgbClr val="5F625C"/>
-                </a:solidFill>
-                <a:latin typeface="Inter"/>
-              </a:rPr>
-              <a:t>GE.MMRI (8,64°S 122,24°E), broadband + akselerometer, Δ≈104 km. Data: GEOFON · ObsPy.</a:t>
-            </a:r>
-          </a:p>
-        </p:txBody>
-      </p:sp>
-      <p:sp>
-        <p:nvSpPr>
-          <p:cNvPr id="8" name="TextBox 7"/>
-          <p:cNvSpPr txBox="1"/>
-          <p:nvPr/>
-        </p:nvSpPr>
-        <p:spPr>
-          <a:xfrm>
-            <a:off x="7635240" y="1965960"/>
-            <a:ext cx="2103120" cy="1097280"/>
-          </a:xfrm>
-          <a:prstGeom prst="rect">
-            <a:avLst/>
-          </a:prstGeom>
-          <a:noFill/>
-        </p:spPr>
-        <p:txBody>
-          <a:bodyPr wrap="square" anchor="t" lIns="0" rIns="0" tIns="0" bIns="0">
-            <a:spAutoFit/>
-          </a:bodyPr>
-          <a:lstStyle/>
-          <a:p>
-            <a:r>
-              <a:rPr sz="4000" b="1" i="0">
-                <a:solidFill>
-                  <a:srgbClr val="8A2D1F"/>
-                </a:solidFill>
-                <a:latin typeface="Source Serif 4"/>
-              </a:rPr>
-              <a:t>0,14 g</a:t>
-            </a:r>
-          </a:p>
-          <a:p>
-            <a:r>
-              <a:rPr sz="1400" b="0" i="0">
-                <a:solidFill>
-                  <a:srgbClr val="5F625C"/>
-                </a:solidFill>
-                <a:latin typeface="Inter"/>
-              </a:rPr>
-              <a:t>PGA (akselerometer)</a:t>
-            </a:r>
-          </a:p>
-        </p:txBody>
-      </p:sp>
-      <p:sp>
-        <p:nvSpPr>
-          <p:cNvPr id="9" name="TextBox 8"/>
-          <p:cNvSpPr txBox="1"/>
-          <p:nvPr/>
-        </p:nvSpPr>
-        <p:spPr>
-          <a:xfrm>
-            <a:off x="9875520" y="1965960"/>
-            <a:ext cx="2103120" cy="1097280"/>
-          </a:xfrm>
-          <a:prstGeom prst="rect">
-            <a:avLst/>
-          </a:prstGeom>
-          <a:noFill/>
-        </p:spPr>
-        <p:txBody>
-          <a:bodyPr wrap="square" anchor="t" lIns="0" rIns="0" tIns="0" bIns="0">
-            <a:spAutoFit/>
-          </a:bodyPr>
-          <a:lstStyle/>
-          <a:p>
-            <a:r>
-              <a:rPr sz="4000" b="1" i="0">
-                <a:solidFill>
-                  <a:srgbClr val="8A2D1F"/>
-                </a:solidFill>
-                <a:latin typeface="Source Serif 4"/>
-              </a:rPr>
-              <a:t>1,9 cm/s</a:t>
-            </a:r>
-          </a:p>
-          <a:p>
-            <a:r>
-              <a:rPr sz="1400" b="0" i="0">
-                <a:solidFill>
-                  <a:srgbClr val="5F625C"/>
-                </a:solidFill>
-                <a:latin typeface="Inter"/>
-              </a:rPr>
-              <a:t>PGV puncak</a:t>
-            </a:r>
-          </a:p>
-        </p:txBody>
-      </p:sp>
-      <p:sp>
-        <p:nvSpPr>
-          <p:cNvPr id="10" name="TextBox 9"/>
-          <p:cNvSpPr txBox="1"/>
-          <p:nvPr/>
-        </p:nvSpPr>
-        <p:spPr>
-          <a:xfrm>
-            <a:off x="7635240" y="3520440"/>
-            <a:ext cx="4206240" cy="4572000"/>
+            <a:off x="566928" y="1783080"/>
+            <a:ext cx="10972800" cy="4572000"/>
           </a:xfrm>
           <a:prstGeom prst="rect">
             <a:avLst/>
@@ -6853,31 +7550,31 @@
               </a:spcAft>
             </a:pPr>
             <a:r>
-              <a:rPr sz="1300" b="1" i="0">
-                <a:solidFill>
-                  <a:srgbClr val="2F5D62"/>
+              <a:rPr sz="1400" b="1" i="0">
+                <a:solidFill>
+                  <a:srgbClr val="8A2D1F"/>
                 </a:solidFill>
                 <a:latin typeface="Inter"/>
               </a:rPr>
               <a:t>■  </a:t>
             </a:r>
             <a:r>
-              <a:rPr sz="1600" b="1" i="0">
+              <a:rPr sz="1700" b="1" i="0">
                 <a:solidFill>
                   <a:srgbClr val="1F1F1B"/>
                 </a:solidFill>
                 <a:latin typeface="Inter"/>
               </a:rPr>
-              <a:t>Jeda waktu asal → gelombang P (~15 dtk): </a:t>
-            </a:r>
-            <a:r>
-              <a:rPr sz="1600" b="0" i="0">
+              <a:t>Menit pertama — membaca “telegram” bumi. </a:t>
+            </a:r>
+            <a:r>
+              <a:rPr sz="1700" b="0" i="0">
                 <a:solidFill>
                   <a:srgbClr val="1F1F1B"/>
                 </a:solidFill>
                 <a:latin typeface="Inter"/>
               </a:rPr>
-              <a:t>gelombang butuh waktu menempuh 104 km.</a:t>
+              <a:t>Gelombang P tiba lebih dulu, membawa lokasi, kedalaman, magnitudo, dan mekanisme dalam hitungan menit.</a:t>
             </a:r>
           </a:p>
           <a:p>
@@ -6890,45 +7587,207 @@
               </a:spcAft>
             </a:pPr>
             <a:r>
-              <a:rPr sz="1300" b="1" i="0">
-                <a:solidFill>
-                  <a:srgbClr val="2F5D62"/>
+              <a:rPr sz="1400" b="1" i="0">
+                <a:solidFill>
+                  <a:srgbClr val="8A2D1F"/>
                 </a:solidFill>
                 <a:latin typeface="Inter"/>
               </a:rPr>
               <a:t>■  </a:t>
             </a:r>
             <a:r>
-              <a:rPr sz="1600" b="1" i="0">
+              <a:rPr sz="1700" b="1" i="0">
                 <a:solidFill>
                   <a:srgbClr val="1F1F1B"/>
                 </a:solidFill>
                 <a:latin typeface="Inter"/>
               </a:rPr>
-              <a:t>Rekaman ini “menyaksikan” runtuhnya terminal Pelabuhan Maumere</a:t>
-            </a:r>
-            <a:r>
-              <a:rPr sz="1600" b="0" i="0">
+              <a:t>ShakeMap. </a:t>
+            </a:r>
+            <a:r>
+              <a:rPr sz="1700" b="0" i="0">
                 <a:solidFill>
                   <a:srgbClr val="1F1F1B"/>
                 </a:solidFill>
                 <a:latin typeface="Inter"/>
               </a:rPr>
-              <a:t> — jembatan ke dampak struktural.</a:t>
-            </a:r>
-          </a:p>
-        </p:txBody>
-      </p:sp>
-      <p:sp>
-        <p:nvSpPr>
-          <p:cNvPr id="11" name="TextBox 10"/>
+              <a:t>Dari satu sumber, kita petakan sebaran guncangan — menebak di mana kerusakan terparah sebelum laporan masuk, untuk mengarahkan SAR.</a:t>
+            </a:r>
+          </a:p>
+          <a:p>
+            <a:pPr>
+              <a:lnSpc>
+                <a:spcPct val="120000"/>
+              </a:lnSpc>
+              <a:spcAft>
+                <a:spcPts val="1200"/>
+              </a:spcAft>
+            </a:pPr>
+            <a:r>
+              <a:rPr sz="1400" b="1" i="0">
+                <a:solidFill>
+                  <a:srgbClr val="8A2D1F"/>
+                </a:solidFill>
+                <a:latin typeface="Inter"/>
+              </a:rPr>
+              <a:t>■  </a:t>
+            </a:r>
+            <a:r>
+              <a:rPr sz="1700" b="1" i="0">
+                <a:solidFill>
+                  <a:srgbClr val="1F1F1B"/>
+                </a:solidFill>
+                <a:latin typeface="Inter"/>
+              </a:rPr>
+              <a:t>Peringatan tsunami. </a:t>
+            </a:r>
+            <a:r>
+              <a:rPr sz="1700" b="0" i="0">
+                <a:solidFill>
+                  <a:srgbClr val="1F1F1B"/>
+                </a:solidFill>
+                <a:latin typeface="Inter"/>
+              </a:rPr>
+              <a:t>Keputusan besar diambil di menit-menit awal (lihat: 2 menit 16 detik).</a:t>
+            </a:r>
+          </a:p>
+          <a:p>
+            <a:pPr>
+              <a:lnSpc>
+                <a:spcPct val="120000"/>
+              </a:lnSpc>
+              <a:spcAft>
+                <a:spcPts val="1200"/>
+              </a:spcAft>
+            </a:pPr>
+            <a:r>
+              <a:rPr sz="1400" b="1" i="0">
+                <a:solidFill>
+                  <a:srgbClr val="8A2D1F"/>
+                </a:solidFill>
+                <a:latin typeface="Inter"/>
+              </a:rPr>
+              <a:t>■  </a:t>
+            </a:r>
+            <a:r>
+              <a:rPr sz="1700" b="1" i="0">
+                <a:solidFill>
+                  <a:srgbClr val="1F1F1B"/>
+                </a:solidFill>
+                <a:latin typeface="Inter"/>
+              </a:rPr>
+              <a:t>Prakiraan gempa susulan. </a:t>
+            </a:r>
+            <a:r>
+              <a:rPr sz="1700" b="0" i="0">
+                <a:solidFill>
+                  <a:srgbClr val="1F1F1B"/>
+                </a:solidFill>
+                <a:latin typeface="Inter"/>
+              </a:rPr>
+              <a:t>Melindungi penyintas dan relawan yang masuk ke bangunan retak.</a:t>
+            </a:r>
+          </a:p>
+        </p:txBody>
+      </p:sp>
+      <p:sp>
+        <p:nvSpPr>
+          <p:cNvPr id="6" name="Rectangle 5"/>
+          <p:cNvSpPr/>
+          <p:nvPr/>
+        </p:nvSpPr>
+        <p:spPr>
+          <a:xfrm>
+            <a:off x="566928" y="4572000"/>
+            <a:ext cx="11064240" cy="1371600"/>
+          </a:xfrm>
+          <a:prstGeom prst="rect">
+            <a:avLst/>
+          </a:prstGeom>
+          <a:solidFill>
+            <a:srgbClr val="F1EEE7"/>
+          </a:solidFill>
+          <a:ln>
+            <a:noFill/>
+          </a:ln>
+          <a:effectLst/>
+        </p:spPr>
+        <p:style>
+          <a:lnRef idx="1">
+            <a:schemeClr val="accent1"/>
+          </a:lnRef>
+          <a:fillRef idx="3">
+            <a:schemeClr val="accent1"/>
+          </a:fillRef>
+          <a:effectRef idx="2">
+            <a:schemeClr val="accent1"/>
+          </a:effectRef>
+          <a:fontRef idx="minor">
+            <a:schemeClr val="lt1"/>
+          </a:fontRef>
+        </p:style>
+        <p:txBody>
+          <a:bodyPr rtlCol="0" anchor="ctr"/>
+          <a:lstStyle/>
+          <a:p>
+            <a:pPr algn="ctr"/>
+          </a:p>
+        </p:txBody>
+      </p:sp>
+      <p:sp>
+        <p:nvSpPr>
+          <p:cNvPr id="7" name="Rectangle 6"/>
+          <p:cNvSpPr/>
+          <p:nvPr/>
+        </p:nvSpPr>
+        <p:spPr>
+          <a:xfrm>
+            <a:off x="566928" y="4572000"/>
+            <a:ext cx="54864" cy="1371600"/>
+          </a:xfrm>
+          <a:prstGeom prst="rect">
+            <a:avLst/>
+          </a:prstGeom>
+          <a:solidFill>
+            <a:srgbClr val="2F5D62"/>
+          </a:solidFill>
+          <a:ln>
+            <a:noFill/>
+          </a:ln>
+          <a:effectLst/>
+        </p:spPr>
+        <p:style>
+          <a:lnRef idx="1">
+            <a:schemeClr val="accent1"/>
+          </a:lnRef>
+          <a:fillRef idx="3">
+            <a:schemeClr val="accent1"/>
+          </a:fillRef>
+          <a:effectRef idx="2">
+            <a:schemeClr val="accent1"/>
+          </a:effectRef>
+          <a:fontRef idx="minor">
+            <a:schemeClr val="lt1"/>
+          </a:fontRef>
+        </p:style>
+        <p:txBody>
+          <a:bodyPr rtlCol="0" anchor="ctr"/>
+          <a:lstStyle/>
+          <a:p>
+            <a:pPr algn="ctr"/>
+          </a:p>
+        </p:txBody>
+      </p:sp>
+      <p:sp>
+        <p:nvSpPr>
+          <p:cNvPr id="8" name="TextBox 7"/>
           <p:cNvSpPr txBox="1"/>
           <p:nvPr/>
         </p:nvSpPr>
         <p:spPr>
           <a:xfrm>
-            <a:off x="566928" y="6355080"/>
-            <a:ext cx="8229600" cy="365760"/>
+            <a:off x="822960" y="4773168"/>
+            <a:ext cx="10607040" cy="1005840"/>
           </a:xfrm>
           <a:prstGeom prst="rect">
             <a:avLst/>
@@ -6941,28 +7800,67 @@
           </a:bodyPr>
           <a:lstStyle/>
           <a:p>
-            <a:r>
-              <a:rPr sz="1050" b="0" i="0">
-                <a:solidFill>
-                  <a:srgbClr val="5F625C"/>
-                </a:solidFill>
-                <a:latin typeface="Inter"/>
-              </a:rPr>
-              <a:t>Data: GEOFON (GFZ) · workflow ObsPy (adaptasi load.py)</a:t>
-            </a:r>
-          </a:p>
-        </p:txBody>
-      </p:sp>
-      <p:sp>
-        <p:nvSpPr>
-          <p:cNvPr id="12" name="TextBox 11"/>
+            <a:pPr>
+              <a:spcAft>
+                <a:spcPts val="600"/>
+              </a:spcAft>
+            </a:pPr>
+            <a:r>
+              <a:rPr sz="1200" b="1" i="0">
+                <a:solidFill>
+                  <a:srgbClr val="2F5D62"/>
+                </a:solidFill>
+                <a:latin typeface="Inter"/>
+              </a:rPr>
+              <a:t>KECEPATAN VS KETELITIAN</a:t>
+            </a:r>
+          </a:p>
+          <a:p>
+            <a:pPr>
+              <a:lnSpc>
+                <a:spcPct val="125000"/>
+              </a:lnSpc>
+            </a:pPr>
+            <a:r>
+              <a:rPr sz="1600" b="0" i="0">
+                <a:solidFill>
+                  <a:srgbClr val="1F1F1B"/>
+                </a:solidFill>
+                <a:latin typeface="Inter"/>
+              </a:rPr>
+              <a:t>Mw 7,7 (USGS) vs 7,61 (GFZ); 10 km vs 25 km. Magnitudo </a:t>
+            </a:r>
+            <a:r>
+              <a:rPr sz="1600" b="1" i="0">
+                <a:solidFill>
+                  <a:srgbClr val="1F1F1B"/>
+                </a:solidFill>
+                <a:latin typeface="Inter"/>
+              </a:rPr>
+              <a:t>direvisi</a:t>
+            </a:r>
+            <a:r>
+              <a:rPr sz="1600" b="0" i="0">
+                <a:solidFill>
+                  <a:srgbClr val="1F1F1B"/>
+                </a:solidFill>
+                <a:latin typeface="Inter"/>
+              </a:rPr>
+              <a:t> seiring data masuk — ini normal, bukan kesalahan. Publik perlu memahaminya.</a:t>
+            </a:r>
+          </a:p>
+        </p:txBody>
+      </p:sp>
+      <p:sp>
+        <p:nvSpPr>
+          <p:cNvPr id="9" name="TextBox 8"/>
           <p:cNvSpPr txBox="1"/>
           <p:nvPr/>
         </p:nvSpPr>
         <p:spPr>
           <a:xfrm>
-            <a:off x="10789920" y="6355080"/>
-            <a:ext cx="914400" cy="365760"/>
+            <a:off x="566928" y="6355080"/>
+            <a:ext cx="8229600" cy="365760"/>
           </a:xfrm>
           <a:prstGeom prst="rect">
             <a:avLst/>
@@ -6975,6 +7873,40 @@
           </a:bodyPr>
           <a:lstStyle/>
           <a:p>
+            <a:r>
+              <a:rPr sz="1050" b="0" i="0">
+                <a:solidFill>
+                  <a:srgbClr val="5F625C"/>
+                </a:solidFill>
+                <a:latin typeface="Inter"/>
+              </a:rPr>
+              <a:t>Peran geofisika dalam rantai tanggap darurat</a:t>
+            </a:r>
+          </a:p>
+        </p:txBody>
+      </p:sp>
+      <p:sp>
+        <p:nvSpPr>
+          <p:cNvPr id="10" name="TextBox 9"/>
+          <p:cNvSpPr txBox="1"/>
+          <p:nvPr/>
+        </p:nvSpPr>
+        <p:spPr>
+          <a:xfrm>
+            <a:off x="10789920" y="6355080"/>
+            <a:ext cx="914400" cy="365760"/>
+          </a:xfrm>
+          <a:prstGeom prst="rect">
+            <a:avLst/>
+          </a:prstGeom>
+          <a:noFill/>
+        </p:spPr>
+        <p:txBody>
+          <a:bodyPr wrap="square" anchor="t" lIns="0" rIns="0" tIns="0" bIns="0">
+            <a:spAutoFit/>
+          </a:bodyPr>
+          <a:lstStyle/>
+          <a:p>
             <a:pPr algn="r"/>
             <a:r>
               <a:rPr sz="1050" b="0" i="0">
@@ -6983,7 +7915,7 @@
                 </a:solidFill>
                 <a:latin typeface="Inter"/>
               </a:rPr>
-              <a:t>7 / 9</a:t>
+              <a:t>7 / 10</a:t>
             </a:r>
           </a:p>
         </p:txBody>
@@ -7075,11 +8007,11 @@
             <a:r>
               <a:rPr sz="1300" b="1" i="0" spc="900">
                 <a:solidFill>
-                  <a:srgbClr val="2F5D62"/>
-                </a:solidFill>
-                <a:latin typeface="Inter"/>
-              </a:rPr>
-              <a:t>DUA PERTANYAAN YANG PALING DITANYA WARGA</a:t>
+                  <a:srgbClr val="8A2D1F"/>
+                </a:solidFill>
+                <a:latin typeface="Inter"/>
+              </a:rPr>
+              <a:t>REKAMAN LANGSUNG — GE.MMRI, MAUMERE</a:t>
             </a:r>
           </a:p>
         </p:txBody>
@@ -7092,8 +8024,8 @@
         </p:nvSpPr>
         <p:spPr>
           <a:xfrm>
-            <a:off x="548640" y="1280160"/>
-            <a:ext cx="5394960" cy="731520"/>
+            <a:off x="548640" y="868680"/>
+            <a:ext cx="11155680" cy="914400"/>
           </a:xfrm>
           <a:prstGeom prst="rect">
             <a:avLst/>
@@ -7106,28 +8038,227 @@
           </a:bodyPr>
           <a:lstStyle/>
           <a:p>
-            <a:r>
-              <a:rPr sz="2200" b="1" i="0">
+            <a:pPr>
+              <a:lnSpc>
+                <a:spcPct val="105000"/>
+              </a:lnSpc>
+            </a:pPr>
+            <a:r>
+              <a:rPr sz="2500" b="1" i="0">
                 <a:solidFill>
                   <a:srgbClr val="1F1F1B"/>
                 </a:solidFill>
                 <a:latin typeface="Source Serif 4"/>
               </a:rPr>
-              <a:t>“Akan ada susulan yang lebih besar?”</a:t>
-            </a:r>
-          </a:p>
-        </p:txBody>
-      </p:sp>
-      <p:sp>
-        <p:nvSpPr>
-          <p:cNvPr id="5" name="TextBox 4"/>
+              <a:t>Guncangan yang meruntuhkan Pelabuhan Maumere, terekam ±104 km dari sumber</a:t>
+            </a:r>
+          </a:p>
+        </p:txBody>
+      </p:sp>
+      <p:sp>
+        <p:nvSpPr>
+          <p:cNvPr id="5" name="Rectangle 4"/>
+          <p:cNvSpPr/>
+          <p:nvPr/>
+        </p:nvSpPr>
+        <p:spPr>
+          <a:xfrm>
+            <a:off x="548640" y="1828800"/>
+            <a:ext cx="6720840" cy="4114800"/>
+          </a:xfrm>
+          <a:prstGeom prst="rect">
+            <a:avLst/>
+          </a:prstGeom>
+          <a:solidFill>
+            <a:srgbClr val="FFFFFF"/>
+          </a:solidFill>
+          <a:ln w="12700">
+            <a:solidFill>
+              <a:srgbClr val="D8D2C5"/>
+            </a:solidFill>
+          </a:ln>
+          <a:effectLst/>
+        </p:spPr>
+        <p:style>
+          <a:lnRef idx="1">
+            <a:schemeClr val="accent1"/>
+          </a:lnRef>
+          <a:fillRef idx="3">
+            <a:schemeClr val="accent1"/>
+          </a:fillRef>
+          <a:effectRef idx="2">
+            <a:schemeClr val="accent1"/>
+          </a:effectRef>
+          <a:fontRef idx="minor">
+            <a:schemeClr val="lt1"/>
+          </a:fontRef>
+        </p:style>
+        <p:txBody>
+          <a:bodyPr rtlCol="0" anchor="ctr"/>
+          <a:lstStyle/>
+          <a:p>
+            <a:pPr algn="ctr"/>
+          </a:p>
+        </p:txBody>
+      </p:sp>
+      <p:pic>
+        <p:nvPicPr>
+          <p:cNvPr id="6" name="Picture 5" descr="waveform_mmri_flores2026.png"/>
+          <p:cNvPicPr>
+            <a:picLocks noChangeAspect="1"/>
+          </p:cNvPicPr>
+          <p:nvPr/>
+        </p:nvPicPr>
+        <p:blipFill>
+          <a:blip r:embed="rId2"/>
+          <a:stretch>
+            <a:fillRect/>
+          </a:stretch>
+        </p:blipFill>
+        <p:spPr>
+          <a:xfrm>
+            <a:off x="658368" y="1938528"/>
+            <a:ext cx="6492240" cy="5553138"/>
+          </a:xfrm>
+          <a:prstGeom prst="rect">
+            <a:avLst/>
+          </a:prstGeom>
+        </p:spPr>
+      </p:pic>
+      <p:sp>
+        <p:nvSpPr>
+          <p:cNvPr id="7" name="TextBox 6"/>
           <p:cNvSpPr txBox="1"/>
           <p:nvPr/>
         </p:nvSpPr>
         <p:spPr>
           <a:xfrm>
-            <a:off x="566928" y="2194560"/>
-            <a:ext cx="5394960" cy="4572000"/>
+            <a:off x="658368" y="5532120"/>
+            <a:ext cx="6492240" cy="365760"/>
+          </a:xfrm>
+          <a:prstGeom prst="rect">
+            <a:avLst/>
+          </a:prstGeom>
+          <a:noFill/>
+        </p:spPr>
+        <p:txBody>
+          <a:bodyPr wrap="square" anchor="t" lIns="0" rIns="0" tIns="0" bIns="0">
+            <a:spAutoFit/>
+          </a:bodyPr>
+          <a:lstStyle/>
+          <a:p>
+            <a:r>
+              <a:rPr sz="1200" b="0" i="0">
+                <a:solidFill>
+                  <a:srgbClr val="5F625C"/>
+                </a:solidFill>
+                <a:latin typeface="Inter"/>
+              </a:rPr>
+              <a:t>GE.MMRI (8,64°S 122,24°E), broadband + akselerometer, Δ≈104 km. Data: GEOFON · ObsPy.</a:t>
+            </a:r>
+          </a:p>
+        </p:txBody>
+      </p:sp>
+      <p:sp>
+        <p:nvSpPr>
+          <p:cNvPr id="8" name="TextBox 7"/>
+          <p:cNvSpPr txBox="1"/>
+          <p:nvPr/>
+        </p:nvSpPr>
+        <p:spPr>
+          <a:xfrm>
+            <a:off x="7635240" y="1965960"/>
+            <a:ext cx="2103120" cy="1097280"/>
+          </a:xfrm>
+          <a:prstGeom prst="rect">
+            <a:avLst/>
+          </a:prstGeom>
+          <a:noFill/>
+        </p:spPr>
+        <p:txBody>
+          <a:bodyPr wrap="square" anchor="t" lIns="0" rIns="0" tIns="0" bIns="0">
+            <a:spAutoFit/>
+          </a:bodyPr>
+          <a:lstStyle/>
+          <a:p>
+            <a:r>
+              <a:rPr sz="4000" b="1" i="0">
+                <a:solidFill>
+                  <a:srgbClr val="8A2D1F"/>
+                </a:solidFill>
+                <a:latin typeface="Source Serif 4"/>
+              </a:rPr>
+              <a:t>0,14 g</a:t>
+            </a:r>
+          </a:p>
+          <a:p>
+            <a:r>
+              <a:rPr sz="1400" b="0" i="0">
+                <a:solidFill>
+                  <a:srgbClr val="5F625C"/>
+                </a:solidFill>
+                <a:latin typeface="Inter"/>
+              </a:rPr>
+              <a:t>PGA (akselerometer)</a:t>
+            </a:r>
+          </a:p>
+        </p:txBody>
+      </p:sp>
+      <p:sp>
+        <p:nvSpPr>
+          <p:cNvPr id="9" name="TextBox 8"/>
+          <p:cNvSpPr txBox="1"/>
+          <p:nvPr/>
+        </p:nvSpPr>
+        <p:spPr>
+          <a:xfrm>
+            <a:off x="9875520" y="1965960"/>
+            <a:ext cx="2103120" cy="1097280"/>
+          </a:xfrm>
+          <a:prstGeom prst="rect">
+            <a:avLst/>
+          </a:prstGeom>
+          <a:noFill/>
+        </p:spPr>
+        <p:txBody>
+          <a:bodyPr wrap="square" anchor="t" lIns="0" rIns="0" tIns="0" bIns="0">
+            <a:spAutoFit/>
+          </a:bodyPr>
+          <a:lstStyle/>
+          <a:p>
+            <a:r>
+              <a:rPr sz="4000" b="1" i="0">
+                <a:solidFill>
+                  <a:srgbClr val="8A2D1F"/>
+                </a:solidFill>
+                <a:latin typeface="Source Serif 4"/>
+              </a:rPr>
+              <a:t>1,9 cm/s</a:t>
+            </a:r>
+          </a:p>
+          <a:p>
+            <a:r>
+              <a:rPr sz="1400" b="0" i="0">
+                <a:solidFill>
+                  <a:srgbClr val="5F625C"/>
+                </a:solidFill>
+                <a:latin typeface="Inter"/>
+              </a:rPr>
+              <a:t>PGV puncak</a:t>
+            </a:r>
+          </a:p>
+        </p:txBody>
+      </p:sp>
+      <p:sp>
+        <p:nvSpPr>
+          <p:cNvPr id="10" name="TextBox 9"/>
+          <p:cNvSpPr txBox="1"/>
+          <p:nvPr/>
+        </p:nvSpPr>
+        <p:spPr>
+          <a:xfrm>
+            <a:off x="7635240" y="3520440"/>
+            <a:ext cx="4206240" cy="4572000"/>
           </a:xfrm>
           <a:prstGeom prst="rect">
             <a:avLst/>
@@ -7149,31 +8280,31 @@
               </a:spcAft>
             </a:pPr>
             <a:r>
-              <a:rPr sz="1400" b="1" i="0">
-                <a:solidFill>
-                  <a:srgbClr val="8A2D1F"/>
+              <a:rPr sz="1300" b="1" i="0">
+                <a:solidFill>
+                  <a:srgbClr val="2F5D62"/>
                 </a:solidFill>
                 <a:latin typeface="Inter"/>
               </a:rPr>
               <a:t>■  </a:t>
             </a:r>
             <a:r>
-              <a:rPr sz="1700" b="1" i="0">
+              <a:rPr sz="1600" b="1" i="0">
                 <a:solidFill>
                   <a:srgbClr val="1F1F1B"/>
                 </a:solidFill>
                 <a:latin typeface="Inter"/>
               </a:rPr>
-              <a:t>&gt;2.768 susulan</a:t>
-            </a:r>
-            <a:r>
-              <a:rPr sz="1700" b="0" i="0">
+              <a:t>Jeda waktu asal → gelombang P (~15 dtk): </a:t>
+            </a:r>
+            <a:r>
+              <a:rPr sz="1600" b="0" i="0">
                 <a:solidFill>
                   <a:srgbClr val="1F1F1B"/>
                 </a:solidFill>
                 <a:latin typeface="Inter"/>
               </a:rPr>
-              <a:t> mengikuti pola peluruhan (hukum Omori): rapat di awal, mereda seiring waktu.</a:t>
+              <a:t>gelombang butuh waktu menempuh 104 km.</a:t>
             </a:r>
           </a:p>
           <a:p>
@@ -7186,142 +8317,45 @@
               </a:spcAft>
             </a:pPr>
             <a:r>
-              <a:rPr sz="1400" b="1" i="0">
-                <a:solidFill>
-                  <a:srgbClr val="8A2D1F"/>
+              <a:rPr sz="1300" b="1" i="0">
+                <a:solidFill>
+                  <a:srgbClr val="2F5D62"/>
                 </a:solidFill>
                 <a:latin typeface="Inter"/>
               </a:rPr>
               <a:t>■  </a:t>
             </a:r>
             <a:r>
-              <a:rPr sz="1700" b="0" i="0">
+              <a:rPr sz="1600" b="1" i="0">
                 <a:solidFill>
                   <a:srgbClr val="1F1F1B"/>
                 </a:solidFill>
                 <a:latin typeface="Inter"/>
               </a:rPr>
-              <a:t>Peluang susulan besar mengecil tiap hari — tapi </a:t>
-            </a:r>
-            <a:r>
-              <a:rPr sz="1700" b="1" i="0">
+              <a:t>Rekaman ini “menyaksikan” runtuhnya terminal Pelabuhan Maumere</a:t>
+            </a:r>
+            <a:r>
+              <a:rPr sz="1600" b="0" i="0">
                 <a:solidFill>
                   <a:srgbClr val="1F1F1B"/>
                 </a:solidFill>
                 <a:latin typeface="Inter"/>
               </a:rPr>
-              <a:t>tak pernah nol</a:t>
-            </a:r>
-            <a:r>
-              <a:rPr sz="1700" b="0" i="0">
-                <a:solidFill>
-                  <a:srgbClr val="1F1F1B"/>
-                </a:solidFill>
-                <a:latin typeface="Inter"/>
-              </a:rPr>
-              <a:t>. Jangan masuk bangunan retak.</a:t>
-            </a:r>
-          </a:p>
-        </p:txBody>
-      </p:sp>
-      <p:sp>
-        <p:nvSpPr>
-          <p:cNvPr id="6" name="Rectangle 5"/>
-          <p:cNvSpPr/>
-          <p:nvPr/>
-        </p:nvSpPr>
-        <p:spPr>
-          <a:xfrm>
-            <a:off x="6400800" y="1737360"/>
-            <a:ext cx="5212080" cy="2194560"/>
-          </a:xfrm>
-          <a:prstGeom prst="rect">
-            <a:avLst/>
-          </a:prstGeom>
-          <a:solidFill>
-            <a:srgbClr val="F1EEE7"/>
-          </a:solidFill>
-          <a:ln>
-            <a:noFill/>
-          </a:ln>
-          <a:effectLst/>
-        </p:spPr>
-        <p:style>
-          <a:lnRef idx="1">
-            <a:schemeClr val="accent1"/>
-          </a:lnRef>
-          <a:fillRef idx="3">
-            <a:schemeClr val="accent1"/>
-          </a:fillRef>
-          <a:effectRef idx="2">
-            <a:schemeClr val="accent1"/>
-          </a:effectRef>
-          <a:fontRef idx="minor">
-            <a:schemeClr val="lt1"/>
-          </a:fontRef>
-        </p:style>
-        <p:txBody>
-          <a:bodyPr rtlCol="0" anchor="ctr"/>
-          <a:lstStyle/>
-          <a:p>
-            <a:pPr algn="ctr"/>
-          </a:p>
-        </p:txBody>
-      </p:sp>
-      <p:sp>
-        <p:nvSpPr>
-          <p:cNvPr id="7" name="Rectangle 6"/>
-          <p:cNvSpPr/>
-          <p:nvPr/>
-        </p:nvSpPr>
-        <p:spPr>
-          <a:xfrm>
-            <a:off x="6400800" y="1737360"/>
-            <a:ext cx="54864" cy="2194560"/>
-          </a:xfrm>
-          <a:prstGeom prst="rect">
-            <a:avLst/>
-          </a:prstGeom>
-          <a:solidFill>
-            <a:srgbClr val="8A2D1F"/>
-          </a:solidFill>
-          <a:ln>
-            <a:noFill/>
-          </a:ln>
-          <a:effectLst/>
-        </p:spPr>
-        <p:style>
-          <a:lnRef idx="1">
-            <a:schemeClr val="accent1"/>
-          </a:lnRef>
-          <a:fillRef idx="3">
-            <a:schemeClr val="accent1"/>
-          </a:fillRef>
-          <a:effectRef idx="2">
-            <a:schemeClr val="accent1"/>
-          </a:effectRef>
-          <a:fontRef idx="minor">
-            <a:schemeClr val="lt1"/>
-          </a:fontRef>
-        </p:style>
-        <p:txBody>
-          <a:bodyPr rtlCol="0" anchor="ctr"/>
-          <a:lstStyle/>
-          <a:p>
-            <a:pPr algn="ctr"/>
-          </a:p>
-        </p:txBody>
-      </p:sp>
-      <p:sp>
-        <p:nvSpPr>
-          <p:cNvPr id="8" name="TextBox 7"/>
+              <a:t> — jembatan ke dampak struktural.</a:t>
+            </a:r>
+          </a:p>
+        </p:txBody>
+      </p:sp>
+      <p:sp>
+        <p:nvSpPr>
+          <p:cNvPr id="11" name="TextBox 10"/>
           <p:cNvSpPr txBox="1"/>
           <p:nvPr/>
         </p:nvSpPr>
         <p:spPr>
           <a:xfrm>
-            <a:off x="6656832" y="1938528"/>
-            <a:ext cx="4754880" cy="1828800"/>
+            <a:off x="566928" y="6355080"/>
+            <a:ext cx="8229600" cy="365760"/>
           </a:xfrm>
           <a:prstGeom prst="rect">
             <a:avLst/>
@@ -7334,85 +8368,28 @@
           </a:bodyPr>
           <a:lstStyle/>
           <a:p>
-            <a:pPr>
-              <a:spcAft>
-                <a:spcPts val="600"/>
-              </a:spcAft>
-            </a:pPr>
-            <a:r>
-              <a:rPr sz="1200" b="1" i="0">
-                <a:solidFill>
-                  <a:srgbClr val="8A2D1F"/>
-                </a:solidFill>
-                <a:latin typeface="Inter"/>
-              </a:rPr>
-              <a:t>PESAN YANG MENYELAMATKAN</a:t>
-            </a:r>
-          </a:p>
-          <a:p>
-            <a:pPr>
-              <a:lnSpc>
-                <a:spcPct val="125000"/>
-              </a:lnSpc>
-            </a:pPr>
-            <a:r>
-              <a:rPr sz="1600" b="0" i="0">
-                <a:solidFill>
-                  <a:srgbClr val="1F1F1B"/>
-                </a:solidFill>
-                <a:latin typeface="Inter"/>
-              </a:rPr>
-              <a:t>Untuk tsunami dekat-pantai, </a:t>
-            </a:r>
-            <a:r>
-              <a:rPr sz="1600" b="1" i="0">
-                <a:solidFill>
-                  <a:srgbClr val="1F1F1B"/>
-                </a:solidFill>
-                <a:latin typeface="Inter"/>
-              </a:rPr>
-              <a:t>guncangan kuat itu sendiri adalah peringatan.</a:t>
-            </a:r>
-            <a:r>
-              <a:rPr sz="1600" b="0" i="0">
-                <a:solidFill>
-                  <a:srgbClr val="1F1F1B"/>
-                </a:solidFill>
-                <a:latin typeface="Inter"/>
-              </a:rPr>
-              <a:t> Jangan tunggu sirene — </a:t>
-            </a:r>
-            <a:r>
-              <a:rPr sz="1600" b="1" i="0">
-                <a:solidFill>
-                  <a:srgbClr val="1F1F1B"/>
-                </a:solidFill>
-                <a:latin typeface="Inter"/>
-              </a:rPr>
-              <a:t>segera evakuasi mandiri</a:t>
-            </a:r>
-            <a:r>
-              <a:rPr sz="1600" b="0" i="0">
-                <a:solidFill>
-                  <a:srgbClr val="1F1F1B"/>
-                </a:solidFill>
-                <a:latin typeface="Inter"/>
-              </a:rPr>
-              <a:t> ke tempat tinggi.</a:t>
-            </a:r>
-          </a:p>
-        </p:txBody>
-      </p:sp>
-      <p:sp>
-        <p:nvSpPr>
-          <p:cNvPr id="9" name="TextBox 8"/>
+            <a:r>
+              <a:rPr sz="1050" b="0" i="0">
+                <a:solidFill>
+                  <a:srgbClr val="5F625C"/>
+                </a:solidFill>
+                <a:latin typeface="Inter"/>
+              </a:rPr>
+              <a:t>Data: GEOFON (GFZ) · workflow ObsPy (adaptasi load.py)</a:t>
+            </a:r>
+          </a:p>
+        </p:txBody>
+      </p:sp>
+      <p:sp>
+        <p:nvSpPr>
+          <p:cNvPr id="12" name="TextBox 11"/>
           <p:cNvSpPr txBox="1"/>
           <p:nvPr/>
         </p:nvSpPr>
         <p:spPr>
           <a:xfrm>
-            <a:off x="6400800" y="4114800"/>
-            <a:ext cx="5212080" cy="731520"/>
+            <a:off x="10789920" y="6355080"/>
+            <a:ext cx="914400" cy="365760"/>
           </a:xfrm>
           <a:prstGeom prst="rect">
             <a:avLst/>
@@ -7425,83 +8402,15 @@
           </a:bodyPr>
           <a:lstStyle/>
           <a:p>
-            <a:r>
-              <a:rPr sz="1500" b="0" i="1">
+            <a:pPr algn="r"/>
+            <a:r>
+              <a:rPr sz="1050" b="0" i="0">
                 <a:solidFill>
                   <a:srgbClr val="5F625C"/>
                 </a:solidFill>
                 <a:latin typeface="Inter"/>
               </a:rPr>
-              <a:t>1992: tsunami Flores tiba dalam hitungan menit. Waktu adalah nyawa.</a:t>
-            </a:r>
-          </a:p>
-        </p:txBody>
-      </p:sp>
-      <p:sp>
-        <p:nvSpPr>
-          <p:cNvPr id="10" name="TextBox 9"/>
-          <p:cNvSpPr txBox="1"/>
-          <p:nvPr/>
-        </p:nvSpPr>
-        <p:spPr>
-          <a:xfrm>
-            <a:off x="566928" y="6355080"/>
-            <a:ext cx="8229600" cy="365760"/>
-          </a:xfrm>
-          <a:prstGeom prst="rect">
-            <a:avLst/>
-          </a:prstGeom>
-          <a:noFill/>
-        </p:spPr>
-        <p:txBody>
-          <a:bodyPr wrap="square" anchor="t" lIns="0" rIns="0" tIns="0" bIns="0">
-            <a:spAutoFit/>
-          </a:bodyPr>
-          <a:lstStyle/>
-          <a:p>
-            <a:r>
-              <a:rPr sz="1050" b="0" i="0">
-                <a:solidFill>
-                  <a:srgbClr val="5F625C"/>
-                </a:solidFill>
-                <a:latin typeface="Inter"/>
-              </a:rPr>
-              <a:t>Komunikasi risiko saat darurat</a:t>
-            </a:r>
-          </a:p>
-        </p:txBody>
-      </p:sp>
-      <p:sp>
-        <p:nvSpPr>
-          <p:cNvPr id="11" name="TextBox 10"/>
-          <p:cNvSpPr txBox="1"/>
-          <p:nvPr/>
-        </p:nvSpPr>
-        <p:spPr>
-          <a:xfrm>
-            <a:off x="10789920" y="6355080"/>
-            <a:ext cx="914400" cy="365760"/>
-          </a:xfrm>
-          <a:prstGeom prst="rect">
-            <a:avLst/>
-          </a:prstGeom>
-          <a:noFill/>
-        </p:spPr>
-        <p:txBody>
-          <a:bodyPr wrap="square" anchor="t" lIns="0" rIns="0" tIns="0" bIns="0">
-            <a:spAutoFit/>
-          </a:bodyPr>
-          <a:lstStyle/>
-          <a:p>
-            <a:pPr algn="r"/>
-            <a:r>
-              <a:rPr sz="1050" b="0" i="0">
-                <a:solidFill>
-                  <a:srgbClr val="5F625C"/>
-                </a:solidFill>
-                <a:latin typeface="Inter"/>
-              </a:rPr>
-              <a:t>8 / 9</a:t>
+              <a:t>8 / 10</a:t>
             </a:r>
           </a:p>
         </p:txBody>
@@ -7597,7 +8506,7 @@
                 </a:solidFill>
                 <a:latin typeface="Inter"/>
               </a:rPr>
-              <a:t>YANG BISA KITA PERBAIKI</a:t>
+              <a:t>DUA PERTANYAAN YANG PALING DITANYA WARGA</a:t>
             </a:r>
           </a:p>
         </p:txBody>
@@ -7610,8 +8519,8 @@
         </p:nvSpPr>
         <p:spPr>
           <a:xfrm>
-            <a:off x="548640" y="1051560"/>
-            <a:ext cx="10972800" cy="914400"/>
+            <a:off x="548640" y="1280160"/>
+            <a:ext cx="5394960" cy="731520"/>
           </a:xfrm>
           <a:prstGeom prst="rect">
             <a:avLst/>
@@ -7625,22 +8534,13 @@
           <a:lstStyle/>
           <a:p>
             <a:r>
-              <a:rPr sz="3600" b="1" i="0">
+              <a:rPr sz="2200" b="1" i="0">
                 <a:solidFill>
                   <a:srgbClr val="1F1F1B"/>
                 </a:solidFill>
                 <a:latin typeface="Source Serif 4"/>
               </a:rPr>
-              <a:t>Indonesia timur butuh </a:t>
-            </a:r>
-            <a:r>
-              <a:rPr sz="3600" b="1" i="0">
-                <a:solidFill>
-                  <a:srgbClr val="8A2D1F"/>
-                </a:solidFill>
-                <a:latin typeface="Source Serif 4"/>
-              </a:rPr>
-              <a:t>lebih banyak mata</a:t>
+              <a:t>“Akan ada susulan yang lebih besar?”</a:t>
             </a:r>
           </a:p>
         </p:txBody>
@@ -7654,7 +8554,7 @@
         <p:spPr>
           <a:xfrm>
             <a:off x="566928" y="2194560"/>
-            <a:ext cx="6400800" cy="4572000"/>
+            <a:ext cx="5394960" cy="4572000"/>
           </a:xfrm>
           <a:prstGeom prst="rect">
             <a:avLst/>
@@ -7672,7 +8572,7 @@
                 <a:spcPct val="120000"/>
               </a:lnSpc>
               <a:spcAft>
-                <a:spcPts val="1400"/>
+                <a:spcPts val="1200"/>
               </a:spcAft>
             </a:pPr>
             <a:r>
@@ -7685,13 +8585,22 @@
               <a:t>■  </a:t>
             </a:r>
             <a:r>
+              <a:rPr sz="1700" b="1" i="0">
+                <a:solidFill>
+                  <a:srgbClr val="1F1F1B"/>
+                </a:solidFill>
+                <a:latin typeface="Inter"/>
+              </a:rPr>
+              <a:t>&gt;2.768 susulan</a:t>
+            </a:r>
+            <a:r>
               <a:rPr sz="1700" b="0" i="0">
                 <a:solidFill>
                   <a:srgbClr val="1F1F1B"/>
                 </a:solidFill>
                 <a:latin typeface="Inter"/>
               </a:rPr>
-              <a:t>Kerapatan stasiun di NTT jauh di bawah Jawa → lokasi lebih tak pasti, respons lebih lambat.</a:t>
+              <a:t> mengikuti pola peluruhan (hukum Omori): rapat di awal, mereda seiring waktu.</a:t>
             </a:r>
           </a:p>
           <a:p>
@@ -7700,7 +8609,7 @@
                 <a:spcPct val="120000"/>
               </a:lnSpc>
               <a:spcAft>
-                <a:spcPts val="1400"/>
+                <a:spcPts val="1200"/>
               </a:spcAft>
             </a:pPr>
             <a:r>
@@ -7713,13 +8622,22 @@
               <a:t>■  </a:t>
             </a:r>
             <a:r>
+              <a:rPr sz="1700" b="0" i="0">
+                <a:solidFill>
+                  <a:srgbClr val="1F1F1B"/>
+                </a:solidFill>
+                <a:latin typeface="Inter"/>
+              </a:rPr>
+              <a:t>Peluang susulan besar mengecil tiap hari — tapi </a:t>
+            </a:r>
+            <a:r>
               <a:rPr sz="1700" b="1" i="0">
                 <a:solidFill>
                   <a:srgbClr val="1F1F1B"/>
                 </a:solidFill>
                 <a:latin typeface="Inter"/>
               </a:rPr>
-              <a:t>Seismometer biaya rendah &amp; jaringan berbasis komunitas–sekolah</a:t>
+              <a:t>tak pernah nol</a:t>
             </a:r>
             <a:r>
               <a:rPr sz="1700" b="0" i="0">
@@ -7728,35 +8646,7 @@
                 </a:solidFill>
                 <a:latin typeface="Inter"/>
               </a:rPr>
-              <a:t> — merapatkan pemantauan sekaligus membangun kesadaran.</a:t>
-            </a:r>
-          </a:p>
-          <a:p>
-            <a:pPr>
-              <a:lnSpc>
-                <a:spcPct val="120000"/>
-              </a:lnSpc>
-              <a:spcAft>
-                <a:spcPts val="1400"/>
-              </a:spcAft>
-            </a:pPr>
-            <a:r>
-              <a:rPr sz="1400" b="1" i="0">
-                <a:solidFill>
-                  <a:srgbClr val="8A2D1F"/>
-                </a:solidFill>
-                <a:latin typeface="Inter"/>
-              </a:rPr>
-              <a:t>■  </a:t>
-            </a:r>
-            <a:r>
-              <a:rPr sz="1700" b="0" i="0">
-                <a:solidFill>
-                  <a:srgbClr val="1F1F1B"/>
-                </a:solidFill>
-                <a:latin typeface="Inter"/>
-              </a:rPr>
-              <a:t>Penyebaran alat sementara pasca-gempa untuk memantau susulan &amp; memetakan sesar aktif.</a:t>
+              <a:t>. Jangan masuk bangunan retak.</a:t>
             </a:r>
           </a:p>
         </p:txBody>
@@ -7769,8 +8659,8 @@
         </p:nvSpPr>
         <p:spPr>
           <a:xfrm>
-            <a:off x="7315200" y="2194560"/>
-            <a:ext cx="4297680" cy="2377440"/>
+            <a:off x="6400800" y="1737360"/>
+            <a:ext cx="5212080" cy="2194560"/>
           </a:xfrm>
           <a:prstGeom prst="rect">
             <a:avLst/>
@@ -7813,14 +8703,14 @@
         </p:nvSpPr>
         <p:spPr>
           <a:xfrm>
-            <a:off x="7315200" y="2194560"/>
-            <a:ext cx="54864" cy="2377440"/>
+            <a:off x="6400800" y="1737360"/>
+            <a:ext cx="54864" cy="2194560"/>
           </a:xfrm>
           <a:prstGeom prst="rect">
             <a:avLst/>
           </a:prstGeom>
           <a:solidFill>
-            <a:srgbClr val="2F5D62"/>
+            <a:srgbClr val="8A2D1F"/>
           </a:solidFill>
           <a:ln>
             <a:noFill/>
@@ -7857,8 +8747,8 @@
         </p:nvSpPr>
         <p:spPr>
           <a:xfrm>
-            <a:off x="7571231" y="2395728"/>
-            <a:ext cx="3840480" cy="2011680"/>
+            <a:off x="6656832" y="1938528"/>
+            <a:ext cx="4754880" cy="1828800"/>
           </a:xfrm>
           <a:prstGeom prst="rect">
             <a:avLst/>
@@ -7879,11 +8769,11 @@
             <a:r>
               <a:rPr sz="1200" b="1" i="0">
                 <a:solidFill>
-                  <a:srgbClr val="2F5D62"/>
-                </a:solidFill>
-                <a:latin typeface="Inter"/>
-              </a:rPr>
-              <a:t>PENUTUP</a:t>
+                  <a:srgbClr val="8A2D1F"/>
+                </a:solidFill>
+                <a:latin typeface="Inter"/>
+              </a:rPr>
+              <a:t>PESAN YANG MENYELAMATKAN</a:t>
             </a:r>
           </a:p>
           <a:p>
@@ -7899,7 +8789,7 @@
                 </a:solidFill>
                 <a:latin typeface="Inter"/>
               </a:rPr>
-              <a:t>Kita tak bisa mencegah gempa. Tapi setiap sensor tambahan dan setiap warga yang tahu harus </a:t>
+              <a:t>Untuk tsunami dekat-pantai, </a:t>
             </a:r>
             <a:r>
               <a:rPr sz="1600" b="1" i="0">
@@ -7908,7 +8798,7 @@
                 </a:solidFill>
                 <a:latin typeface="Inter"/>
               </a:rPr>
-              <a:t>segera lari ke tempat tinggi</a:t>
+              <a:t>guncangan kuat itu sendiri adalah peringatan.</a:t>
             </a:r>
             <a:r>
               <a:rPr sz="1600" b="0" i="0">
@@ -7917,7 +8807,25 @@
                 </a:solidFill>
                 <a:latin typeface="Inter"/>
               </a:rPr>
-              <a:t> memperbesar peluang kita selamat saat gempa berikutnya datang.</a:t>
+              <a:t> Jangan tunggu sirene — </a:t>
+            </a:r>
+            <a:r>
+              <a:rPr sz="1600" b="1" i="0">
+                <a:solidFill>
+                  <a:srgbClr val="1F1F1B"/>
+                </a:solidFill>
+                <a:latin typeface="Inter"/>
+              </a:rPr>
+              <a:t>segera evakuasi mandiri</a:t>
+            </a:r>
+            <a:r>
+              <a:rPr sz="1600" b="0" i="0">
+                <a:solidFill>
+                  <a:srgbClr val="1F1F1B"/>
+                </a:solidFill>
+                <a:latin typeface="Inter"/>
+              </a:rPr>
+              <a:t> ke tempat tinggi.</a:t>
             </a:r>
           </a:p>
         </p:txBody>
@@ -7930,8 +8838,8 @@
         </p:nvSpPr>
         <p:spPr>
           <a:xfrm>
-            <a:off x="566928" y="5120640"/>
-            <a:ext cx="10972800" cy="548640"/>
+            <a:off x="6400800" y="4114800"/>
+            <a:ext cx="5212080" cy="731520"/>
           </a:xfrm>
           <a:prstGeom prst="rect">
             <a:avLst/>
@@ -7945,22 +8853,13 @@
           <a:lstStyle/>
           <a:p>
             <a:r>
-              <a:rPr sz="1700" b="1" i="0">
-                <a:solidFill>
-                  <a:srgbClr val="1F1F1B"/>
-                </a:solidFill>
-                <a:latin typeface="Inter"/>
-              </a:rPr>
-              <a:t>Dr.rer.nat. Wiwit Suryanto</a:t>
-            </a:r>
-            <a:r>
-              <a:rPr sz="1700" b="0" i="0">
+              <a:rPr sz="1500" b="0" i="1">
                 <a:solidFill>
                   <a:srgbClr val="5F625C"/>
                 </a:solidFill>
                 <a:latin typeface="Inter"/>
               </a:rPr>
-              <a:t>  ·  Geoscience Research Group, Departemen Fisika, FMIPA UGM  ·  Terima kasih.</a:t>
+              <a:t>1992: tsunami Flores tiba dalam hitungan menit. Waktu adalah nyawa.</a:t>
             </a:r>
           </a:p>
         </p:txBody>
@@ -7994,7 +8893,7 @@
                 </a:solidFill>
                 <a:latin typeface="Inter"/>
               </a:rPr>
-              <a:t>Diskusi Publik PSBA UGM — Respons Tanggap Darurat Gempa NTT</a:t>
+              <a:t>Komunikasi risiko saat darurat</a:t>
             </a:r>
           </a:p>
         </p:txBody>
@@ -8029,7 +8928,7 @@
                 </a:solidFill>
                 <a:latin typeface="Inter"/>
               </a:rPr>
-              <a:t>9 / 9</a:t>
+              <a:t>9 / 10</a:t>
             </a:r>
           </a:p>
         </p:txBody>

</xml_diff>

<commit_message>
Add Wichmann historical earthquake map slide to Flores talk
New slide 7/11: relief map of historical earthquakes/seaquakes/tsunamis across
NTT from Arthur Wichmann's catalogue (to 1877), reinforcing that the hazard was
recorded long before instruments. Deck footers now auto-number in JS (no manual
renumbering on insert); regenerate PDF and PPTX; add the map to the talk page
figures.

Co-Authored-By: Claude Opus 4.8 <noreply@anthropic.com>
</commit_message>
<xml_diff>
--- a/.design/design-system/elegant-minimalist/outputs/talk-flores-2026/Diskusi_Publik_Gempa_Flores_2026_Wiwit_Suryanto.pptx
+++ b/.design/design-system/elegant-minimalist/outputs/talk-flores-2026/Diskusi_Publik_Gempa_Flores_2026_Wiwit_Suryanto.pptx
@@ -15,6 +15,7 @@
     <p:sldId id="263" r:id="rId14"/>
     <p:sldId id="264" r:id="rId15"/>
     <p:sldId id="265" r:id="rId16"/>
+    <p:sldId id="266" r:id="rId17"/>
   </p:sldIdLst>
   <p:sldSz cx="12191695" cy="6858000" type="screen4x3"/>
   <p:notesSz cx="6858000" cy="9144000"/>
@@ -3387,7 +3388,7 @@
                 </a:solidFill>
                 <a:latin typeface="Inter"/>
               </a:rPr>
-              <a:t>1 / 10</a:t>
+              <a:t>1 / 11</a:t>
             </a:r>
           </a:p>
         </p:txBody>
@@ -3483,6 +3484,524 @@
                 </a:solidFill>
                 <a:latin typeface="Inter"/>
               </a:rPr>
+              <a:t>DUA PERTANYAAN YANG PALING DITANYA WARGA</a:t>
+            </a:r>
+          </a:p>
+        </p:txBody>
+      </p:sp>
+      <p:sp>
+        <p:nvSpPr>
+          <p:cNvPr id="4" name="TextBox 3"/>
+          <p:cNvSpPr txBox="1"/>
+          <p:nvPr/>
+        </p:nvSpPr>
+        <p:spPr>
+          <a:xfrm>
+            <a:off x="548640" y="1280160"/>
+            <a:ext cx="5394960" cy="731520"/>
+          </a:xfrm>
+          <a:prstGeom prst="rect">
+            <a:avLst/>
+          </a:prstGeom>
+          <a:noFill/>
+        </p:spPr>
+        <p:txBody>
+          <a:bodyPr wrap="square" anchor="t" lIns="0" rIns="0" tIns="0" bIns="0">
+            <a:spAutoFit/>
+          </a:bodyPr>
+          <a:lstStyle/>
+          <a:p>
+            <a:r>
+              <a:rPr sz="2200" b="1" i="0">
+                <a:solidFill>
+                  <a:srgbClr val="1F1F1B"/>
+                </a:solidFill>
+                <a:latin typeface="Source Serif 4"/>
+              </a:rPr>
+              <a:t>“Akan ada susulan yang lebih besar?”</a:t>
+            </a:r>
+          </a:p>
+        </p:txBody>
+      </p:sp>
+      <p:sp>
+        <p:nvSpPr>
+          <p:cNvPr id="5" name="TextBox 4"/>
+          <p:cNvSpPr txBox="1"/>
+          <p:nvPr/>
+        </p:nvSpPr>
+        <p:spPr>
+          <a:xfrm>
+            <a:off x="566928" y="2194560"/>
+            <a:ext cx="5394960" cy="4572000"/>
+          </a:xfrm>
+          <a:prstGeom prst="rect">
+            <a:avLst/>
+          </a:prstGeom>
+          <a:noFill/>
+        </p:spPr>
+        <p:txBody>
+          <a:bodyPr wrap="square" anchor="t" lIns="0" rIns="0" tIns="0" bIns="0">
+            <a:spAutoFit/>
+          </a:bodyPr>
+          <a:lstStyle/>
+          <a:p>
+            <a:pPr>
+              <a:lnSpc>
+                <a:spcPct val="120000"/>
+              </a:lnSpc>
+              <a:spcAft>
+                <a:spcPts val="1200"/>
+              </a:spcAft>
+            </a:pPr>
+            <a:r>
+              <a:rPr sz="1400" b="1" i="0">
+                <a:solidFill>
+                  <a:srgbClr val="8A2D1F"/>
+                </a:solidFill>
+                <a:latin typeface="Inter"/>
+              </a:rPr>
+              <a:t>■  </a:t>
+            </a:r>
+            <a:r>
+              <a:rPr sz="1700" b="1" i="0">
+                <a:solidFill>
+                  <a:srgbClr val="1F1F1B"/>
+                </a:solidFill>
+                <a:latin typeface="Inter"/>
+              </a:rPr>
+              <a:t>&gt;2.768 susulan</a:t>
+            </a:r>
+            <a:r>
+              <a:rPr sz="1700" b="0" i="0">
+                <a:solidFill>
+                  <a:srgbClr val="1F1F1B"/>
+                </a:solidFill>
+                <a:latin typeface="Inter"/>
+              </a:rPr>
+              <a:t> mengikuti pola peluruhan (hukum Omori): rapat di awal, mereda seiring waktu.</a:t>
+            </a:r>
+          </a:p>
+          <a:p>
+            <a:pPr>
+              <a:lnSpc>
+                <a:spcPct val="120000"/>
+              </a:lnSpc>
+              <a:spcAft>
+                <a:spcPts val="1200"/>
+              </a:spcAft>
+            </a:pPr>
+            <a:r>
+              <a:rPr sz="1400" b="1" i="0">
+                <a:solidFill>
+                  <a:srgbClr val="8A2D1F"/>
+                </a:solidFill>
+                <a:latin typeface="Inter"/>
+              </a:rPr>
+              <a:t>■  </a:t>
+            </a:r>
+            <a:r>
+              <a:rPr sz="1700" b="0" i="0">
+                <a:solidFill>
+                  <a:srgbClr val="1F1F1B"/>
+                </a:solidFill>
+                <a:latin typeface="Inter"/>
+              </a:rPr>
+              <a:t>Peluang susulan besar mengecil tiap hari — tapi </a:t>
+            </a:r>
+            <a:r>
+              <a:rPr sz="1700" b="1" i="0">
+                <a:solidFill>
+                  <a:srgbClr val="1F1F1B"/>
+                </a:solidFill>
+                <a:latin typeface="Inter"/>
+              </a:rPr>
+              <a:t>tak pernah nol</a:t>
+            </a:r>
+            <a:r>
+              <a:rPr sz="1700" b="0" i="0">
+                <a:solidFill>
+                  <a:srgbClr val="1F1F1B"/>
+                </a:solidFill>
+                <a:latin typeface="Inter"/>
+              </a:rPr>
+              <a:t>. Jangan masuk bangunan retak.</a:t>
+            </a:r>
+          </a:p>
+        </p:txBody>
+      </p:sp>
+      <p:sp>
+        <p:nvSpPr>
+          <p:cNvPr id="6" name="Rectangle 5"/>
+          <p:cNvSpPr/>
+          <p:nvPr/>
+        </p:nvSpPr>
+        <p:spPr>
+          <a:xfrm>
+            <a:off x="6400800" y="1737360"/>
+            <a:ext cx="5212080" cy="2194560"/>
+          </a:xfrm>
+          <a:prstGeom prst="rect">
+            <a:avLst/>
+          </a:prstGeom>
+          <a:solidFill>
+            <a:srgbClr val="F1EEE7"/>
+          </a:solidFill>
+          <a:ln>
+            <a:noFill/>
+          </a:ln>
+          <a:effectLst/>
+        </p:spPr>
+        <p:style>
+          <a:lnRef idx="1">
+            <a:schemeClr val="accent1"/>
+          </a:lnRef>
+          <a:fillRef idx="3">
+            <a:schemeClr val="accent1"/>
+          </a:fillRef>
+          <a:effectRef idx="2">
+            <a:schemeClr val="accent1"/>
+          </a:effectRef>
+          <a:fontRef idx="minor">
+            <a:schemeClr val="lt1"/>
+          </a:fontRef>
+        </p:style>
+        <p:txBody>
+          <a:bodyPr rtlCol="0" anchor="ctr"/>
+          <a:lstStyle/>
+          <a:p>
+            <a:pPr algn="ctr"/>
+          </a:p>
+        </p:txBody>
+      </p:sp>
+      <p:sp>
+        <p:nvSpPr>
+          <p:cNvPr id="7" name="Rectangle 6"/>
+          <p:cNvSpPr/>
+          <p:nvPr/>
+        </p:nvSpPr>
+        <p:spPr>
+          <a:xfrm>
+            <a:off x="6400800" y="1737360"/>
+            <a:ext cx="54864" cy="2194560"/>
+          </a:xfrm>
+          <a:prstGeom prst="rect">
+            <a:avLst/>
+          </a:prstGeom>
+          <a:solidFill>
+            <a:srgbClr val="8A2D1F"/>
+          </a:solidFill>
+          <a:ln>
+            <a:noFill/>
+          </a:ln>
+          <a:effectLst/>
+        </p:spPr>
+        <p:style>
+          <a:lnRef idx="1">
+            <a:schemeClr val="accent1"/>
+          </a:lnRef>
+          <a:fillRef idx="3">
+            <a:schemeClr val="accent1"/>
+          </a:fillRef>
+          <a:effectRef idx="2">
+            <a:schemeClr val="accent1"/>
+          </a:effectRef>
+          <a:fontRef idx="minor">
+            <a:schemeClr val="lt1"/>
+          </a:fontRef>
+        </p:style>
+        <p:txBody>
+          <a:bodyPr rtlCol="0" anchor="ctr"/>
+          <a:lstStyle/>
+          <a:p>
+            <a:pPr algn="ctr"/>
+          </a:p>
+        </p:txBody>
+      </p:sp>
+      <p:sp>
+        <p:nvSpPr>
+          <p:cNvPr id="8" name="TextBox 7"/>
+          <p:cNvSpPr txBox="1"/>
+          <p:nvPr/>
+        </p:nvSpPr>
+        <p:spPr>
+          <a:xfrm>
+            <a:off x="6656832" y="1938528"/>
+            <a:ext cx="4754880" cy="1828800"/>
+          </a:xfrm>
+          <a:prstGeom prst="rect">
+            <a:avLst/>
+          </a:prstGeom>
+          <a:noFill/>
+        </p:spPr>
+        <p:txBody>
+          <a:bodyPr wrap="square" anchor="t" lIns="0" rIns="0" tIns="0" bIns="0">
+            <a:spAutoFit/>
+          </a:bodyPr>
+          <a:lstStyle/>
+          <a:p>
+            <a:pPr>
+              <a:spcAft>
+                <a:spcPts val="600"/>
+              </a:spcAft>
+            </a:pPr>
+            <a:r>
+              <a:rPr sz="1200" b="1" i="0">
+                <a:solidFill>
+                  <a:srgbClr val="8A2D1F"/>
+                </a:solidFill>
+                <a:latin typeface="Inter"/>
+              </a:rPr>
+              <a:t>PESAN YANG MENYELAMATKAN</a:t>
+            </a:r>
+          </a:p>
+          <a:p>
+            <a:pPr>
+              <a:lnSpc>
+                <a:spcPct val="125000"/>
+              </a:lnSpc>
+            </a:pPr>
+            <a:r>
+              <a:rPr sz="1600" b="0" i="0">
+                <a:solidFill>
+                  <a:srgbClr val="1F1F1B"/>
+                </a:solidFill>
+                <a:latin typeface="Inter"/>
+              </a:rPr>
+              <a:t>Untuk tsunami dekat-pantai, </a:t>
+            </a:r>
+            <a:r>
+              <a:rPr sz="1600" b="1" i="0">
+                <a:solidFill>
+                  <a:srgbClr val="1F1F1B"/>
+                </a:solidFill>
+                <a:latin typeface="Inter"/>
+              </a:rPr>
+              <a:t>guncangan kuat itu sendiri adalah peringatan.</a:t>
+            </a:r>
+            <a:r>
+              <a:rPr sz="1600" b="0" i="0">
+                <a:solidFill>
+                  <a:srgbClr val="1F1F1B"/>
+                </a:solidFill>
+                <a:latin typeface="Inter"/>
+              </a:rPr>
+              <a:t> Jangan tunggu sirene — </a:t>
+            </a:r>
+            <a:r>
+              <a:rPr sz="1600" b="1" i="0">
+                <a:solidFill>
+                  <a:srgbClr val="1F1F1B"/>
+                </a:solidFill>
+                <a:latin typeface="Inter"/>
+              </a:rPr>
+              <a:t>segera evakuasi mandiri</a:t>
+            </a:r>
+            <a:r>
+              <a:rPr sz="1600" b="0" i="0">
+                <a:solidFill>
+                  <a:srgbClr val="1F1F1B"/>
+                </a:solidFill>
+                <a:latin typeface="Inter"/>
+              </a:rPr>
+              <a:t> ke tempat tinggi.</a:t>
+            </a:r>
+          </a:p>
+        </p:txBody>
+      </p:sp>
+      <p:sp>
+        <p:nvSpPr>
+          <p:cNvPr id="9" name="TextBox 8"/>
+          <p:cNvSpPr txBox="1"/>
+          <p:nvPr/>
+        </p:nvSpPr>
+        <p:spPr>
+          <a:xfrm>
+            <a:off x="6400800" y="4114800"/>
+            <a:ext cx="5212080" cy="731520"/>
+          </a:xfrm>
+          <a:prstGeom prst="rect">
+            <a:avLst/>
+          </a:prstGeom>
+          <a:noFill/>
+        </p:spPr>
+        <p:txBody>
+          <a:bodyPr wrap="square" anchor="t" lIns="0" rIns="0" tIns="0" bIns="0">
+            <a:spAutoFit/>
+          </a:bodyPr>
+          <a:lstStyle/>
+          <a:p>
+            <a:r>
+              <a:rPr sz="1500" b="0" i="1">
+                <a:solidFill>
+                  <a:srgbClr val="5F625C"/>
+                </a:solidFill>
+                <a:latin typeface="Inter"/>
+              </a:rPr>
+              <a:t>1992: tsunami Flores tiba dalam hitungan menit. Waktu adalah nyawa.</a:t>
+            </a:r>
+          </a:p>
+        </p:txBody>
+      </p:sp>
+      <p:sp>
+        <p:nvSpPr>
+          <p:cNvPr id="10" name="TextBox 9"/>
+          <p:cNvSpPr txBox="1"/>
+          <p:nvPr/>
+        </p:nvSpPr>
+        <p:spPr>
+          <a:xfrm>
+            <a:off x="566928" y="6355080"/>
+            <a:ext cx="8229600" cy="365760"/>
+          </a:xfrm>
+          <a:prstGeom prst="rect">
+            <a:avLst/>
+          </a:prstGeom>
+          <a:noFill/>
+        </p:spPr>
+        <p:txBody>
+          <a:bodyPr wrap="square" anchor="t" lIns="0" rIns="0" tIns="0" bIns="0">
+            <a:spAutoFit/>
+          </a:bodyPr>
+          <a:lstStyle/>
+          <a:p>
+            <a:r>
+              <a:rPr sz="1050" b="0" i="0">
+                <a:solidFill>
+                  <a:srgbClr val="5F625C"/>
+                </a:solidFill>
+                <a:latin typeface="Inter"/>
+              </a:rPr>
+              <a:t>Komunikasi risiko saat darurat</a:t>
+            </a:r>
+          </a:p>
+        </p:txBody>
+      </p:sp>
+      <p:sp>
+        <p:nvSpPr>
+          <p:cNvPr id="11" name="TextBox 10"/>
+          <p:cNvSpPr txBox="1"/>
+          <p:nvPr/>
+        </p:nvSpPr>
+        <p:spPr>
+          <a:xfrm>
+            <a:off x="10789920" y="6355080"/>
+            <a:ext cx="914400" cy="365760"/>
+          </a:xfrm>
+          <a:prstGeom prst="rect">
+            <a:avLst/>
+          </a:prstGeom>
+          <a:noFill/>
+        </p:spPr>
+        <p:txBody>
+          <a:bodyPr wrap="square" anchor="t" lIns="0" rIns="0" tIns="0" bIns="0">
+            <a:spAutoFit/>
+          </a:bodyPr>
+          <a:lstStyle/>
+          <a:p>
+            <a:pPr algn="r"/>
+            <a:r>
+              <a:rPr sz="1050" b="0" i="0">
+                <a:solidFill>
+                  <a:srgbClr val="5F625C"/>
+                </a:solidFill>
+                <a:latin typeface="Inter"/>
+              </a:rPr>
+              <a:t>10 / 11</a:t>
+            </a:r>
+          </a:p>
+        </p:txBody>
+      </p:sp>
+    </p:spTree>
+  </p:cSld>
+  <p:clrMapOvr>
+    <a:masterClrMapping/>
+  </p:clrMapOvr>
+</p:sld>
+</file>
+
+<file path=ppt/slides/slide11.xml><?xml version="1.0" encoding="utf-8"?>
+<p:sld xmlns:a="http://schemas.openxmlformats.org/drawingml/2006/main" xmlns:p="http://schemas.openxmlformats.org/presentationml/2006/main" xmlns:r="http://schemas.openxmlformats.org/officeDocument/2006/relationships">
+  <p:cSld>
+    <p:spTree>
+      <p:nvGrpSpPr>
+        <p:cNvPr id="1" name=""/>
+        <p:cNvGrpSpPr/>
+        <p:nvPr/>
+      </p:nvGrpSpPr>
+      <p:grpSpPr/>
+      <p:sp>
+        <p:nvSpPr>
+          <p:cNvPr id="2" name="Rectangle 1"/>
+          <p:cNvSpPr/>
+          <p:nvPr/>
+        </p:nvSpPr>
+        <p:spPr>
+          <a:xfrm>
+            <a:off x="0" y="0"/>
+            <a:ext cx="12191695" cy="6858000"/>
+          </a:xfrm>
+          <a:prstGeom prst="rect">
+            <a:avLst/>
+          </a:prstGeom>
+          <a:solidFill>
+            <a:srgbClr val="F8F6F1"/>
+          </a:solidFill>
+          <a:ln>
+            <a:noFill/>
+          </a:ln>
+          <a:effectLst/>
+        </p:spPr>
+        <p:style>
+          <a:lnRef idx="1">
+            <a:schemeClr val="accent1"/>
+          </a:lnRef>
+          <a:fillRef idx="3">
+            <a:schemeClr val="accent1"/>
+          </a:fillRef>
+          <a:effectRef idx="2">
+            <a:schemeClr val="accent1"/>
+          </a:effectRef>
+          <a:fontRef idx="minor">
+            <a:schemeClr val="lt1"/>
+          </a:fontRef>
+        </p:style>
+        <p:txBody>
+          <a:bodyPr rtlCol="0" anchor="ctr"/>
+          <a:lstStyle/>
+          <a:p>
+            <a:pPr algn="ctr"/>
+          </a:p>
+        </p:txBody>
+      </p:sp>
+      <p:sp>
+        <p:nvSpPr>
+          <p:cNvPr id="3" name="TextBox 2"/>
+          <p:cNvSpPr txBox="1"/>
+          <p:nvPr/>
+        </p:nvSpPr>
+        <p:spPr>
+          <a:xfrm>
+            <a:off x="566928" y="457200"/>
+            <a:ext cx="10058400" cy="365760"/>
+          </a:xfrm>
+          <a:prstGeom prst="rect">
+            <a:avLst/>
+          </a:prstGeom>
+          <a:noFill/>
+        </p:spPr>
+        <p:txBody>
+          <a:bodyPr wrap="square" anchor="t" lIns="0" rIns="0" tIns="0" bIns="0">
+            <a:spAutoFit/>
+          </a:bodyPr>
+          <a:lstStyle/>
+          <a:p>
+            <a:r>
+              <a:rPr sz="1300" b="1" i="0" spc="900">
+                <a:solidFill>
+                  <a:srgbClr val="2F5D62"/>
+                </a:solidFill>
+                <a:latin typeface="Inter"/>
+              </a:rPr>
               <a:t>YANG BISA KITA PERBAIKI</a:t>
             </a:r>
           </a:p>
@@ -3915,7 +4434,7 @@
                 </a:solidFill>
                 <a:latin typeface="Inter"/>
               </a:rPr>
-              <a:t>10 / 10</a:t>
+              <a:t>11 / 11</a:t>
             </a:r>
           </a:p>
         </p:txBody>
@@ -4218,7 +4737,7 @@
                 </a:solidFill>
                 <a:latin typeface="Inter"/>
               </a:rPr>
-              <a:t>2 / 10</a:t>
+              <a:t>2 / 11</a:t>
             </a:r>
           </a:p>
         </p:txBody>
@@ -4615,7 +5134,7 @@
                 </a:solidFill>
                 <a:latin typeface="Inter"/>
               </a:rPr>
-              <a:t>3 / 10</a:t>
+              <a:t>3 / 11</a:t>
             </a:r>
           </a:p>
         </p:txBody>
@@ -5748,7 +6267,7 @@
                 </a:solidFill>
                 <a:latin typeface="Inter"/>
               </a:rPr>
-              <a:t>4 / 10</a:t>
+              <a:t>4 / 11</a:t>
             </a:r>
           </a:p>
         </p:txBody>
@@ -6486,7 +7005,7 @@
                 </a:solidFill>
                 <a:latin typeface="Inter"/>
               </a:rPr>
-              <a:t>5 / 10</a:t>
+              <a:t>5 / 11</a:t>
             </a:r>
           </a:p>
         </p:txBody>
@@ -7384,7 +7903,7 @@
                 </a:solidFill>
                 <a:latin typeface="Inter"/>
               </a:rPr>
-              <a:t>6 / 10</a:t>
+              <a:t>6 / 11</a:t>
             </a:r>
           </a:p>
         </p:txBody>
@@ -7480,7 +7999,7 @@
                 </a:solidFill>
                 <a:latin typeface="Inter"/>
               </a:rPr>
-              <a:t>72 JAM PERTAMA</a:t>
+              <a:t>PETA GEMPA HISTORIS — KATALOG WICHMANN</a:t>
             </a:r>
           </a:p>
         </p:txBody>
@@ -7494,7 +8013,7 @@
         <p:spPr>
           <a:xfrm>
             <a:off x="548640" y="868680"/>
-            <a:ext cx="10972800" cy="640080"/>
+            <a:ext cx="11064240" cy="640080"/>
           </a:xfrm>
           <a:prstGeom prst="rect">
             <a:avLst/>
@@ -7508,207 +8027,38 @@
           <a:lstStyle/>
           <a:p>
             <a:r>
-              <a:rPr sz="2600" b="1" i="0">
+              <a:rPr sz="2500" b="1" i="0">
                 <a:solidFill>
                   <a:srgbClr val="1F1F1B"/>
                 </a:solidFill>
                 <a:latin typeface="Source Serif 4"/>
               </a:rPr>
-              <a:t>Apa yang dikerjakan seismologi saat tanggap darurat</a:t>
-            </a:r>
-          </a:p>
-        </p:txBody>
-      </p:sp>
-      <p:sp>
-        <p:nvSpPr>
-          <p:cNvPr id="5" name="TextBox 4"/>
-          <p:cNvSpPr txBox="1"/>
-          <p:nvPr/>
-        </p:nvSpPr>
-        <p:spPr>
-          <a:xfrm>
-            <a:off x="566928" y="1783080"/>
-            <a:ext cx="10972800" cy="4572000"/>
-          </a:xfrm>
-          <a:prstGeom prst="rect">
-            <a:avLst/>
-          </a:prstGeom>
-          <a:noFill/>
-        </p:spPr>
-        <p:txBody>
-          <a:bodyPr wrap="square" anchor="t" lIns="0" rIns="0" tIns="0" bIns="0">
-            <a:spAutoFit/>
-          </a:bodyPr>
-          <a:lstStyle/>
-          <a:p>
-            <a:pPr>
-              <a:lnSpc>
-                <a:spcPct val="120000"/>
-              </a:lnSpc>
-              <a:spcAft>
-                <a:spcPts val="1200"/>
-              </a:spcAft>
-            </a:pPr>
-            <a:r>
-              <a:rPr sz="1400" b="1" i="0">
-                <a:solidFill>
-                  <a:srgbClr val="8A2D1F"/>
-                </a:solidFill>
-                <a:latin typeface="Inter"/>
-              </a:rPr>
-              <a:t>■  </a:t>
-            </a:r>
-            <a:r>
-              <a:rPr sz="1700" b="1" i="0">
-                <a:solidFill>
-                  <a:srgbClr val="1F1F1B"/>
-                </a:solidFill>
-                <a:latin typeface="Inter"/>
-              </a:rPr>
-              <a:t>Menit pertama — membaca “telegram” bumi. </a:t>
-            </a:r>
-            <a:r>
-              <a:rPr sz="1700" b="0" i="0">
-                <a:solidFill>
-                  <a:srgbClr val="1F1F1B"/>
-                </a:solidFill>
-                <a:latin typeface="Inter"/>
-              </a:rPr>
-              <a:t>Gelombang P tiba lebih dulu, membawa lokasi, kedalaman, magnitudo, dan mekanisme dalam hitungan menit.</a:t>
-            </a:r>
-          </a:p>
-          <a:p>
-            <a:pPr>
-              <a:lnSpc>
-                <a:spcPct val="120000"/>
-              </a:lnSpc>
-              <a:spcAft>
-                <a:spcPts val="1200"/>
-              </a:spcAft>
-            </a:pPr>
-            <a:r>
-              <a:rPr sz="1400" b="1" i="0">
-                <a:solidFill>
-                  <a:srgbClr val="8A2D1F"/>
-                </a:solidFill>
-                <a:latin typeface="Inter"/>
-              </a:rPr>
-              <a:t>■  </a:t>
-            </a:r>
-            <a:r>
-              <a:rPr sz="1700" b="1" i="0">
-                <a:solidFill>
-                  <a:srgbClr val="1F1F1B"/>
-                </a:solidFill>
-                <a:latin typeface="Inter"/>
-              </a:rPr>
-              <a:t>ShakeMap. </a:t>
-            </a:r>
-            <a:r>
-              <a:rPr sz="1700" b="0" i="0">
-                <a:solidFill>
-                  <a:srgbClr val="1F1F1B"/>
-                </a:solidFill>
-                <a:latin typeface="Inter"/>
-              </a:rPr>
-              <a:t>Dari satu sumber, kita petakan sebaran guncangan — menebak di mana kerusakan terparah sebelum laporan masuk, untuk mengarahkan SAR.</a:t>
-            </a:r>
-          </a:p>
-          <a:p>
-            <a:pPr>
-              <a:lnSpc>
-                <a:spcPct val="120000"/>
-              </a:lnSpc>
-              <a:spcAft>
-                <a:spcPts val="1200"/>
-              </a:spcAft>
-            </a:pPr>
-            <a:r>
-              <a:rPr sz="1400" b="1" i="0">
-                <a:solidFill>
-                  <a:srgbClr val="8A2D1F"/>
-                </a:solidFill>
-                <a:latin typeface="Inter"/>
-              </a:rPr>
-              <a:t>■  </a:t>
-            </a:r>
-            <a:r>
-              <a:rPr sz="1700" b="1" i="0">
-                <a:solidFill>
-                  <a:srgbClr val="1F1F1B"/>
-                </a:solidFill>
-                <a:latin typeface="Inter"/>
-              </a:rPr>
-              <a:t>Peringatan tsunami. </a:t>
-            </a:r>
-            <a:r>
-              <a:rPr sz="1700" b="0" i="0">
-                <a:solidFill>
-                  <a:srgbClr val="1F1F1B"/>
-                </a:solidFill>
-                <a:latin typeface="Inter"/>
-              </a:rPr>
-              <a:t>Keputusan besar diambil di menit-menit awal (lihat: 2 menit 16 detik).</a:t>
-            </a:r>
-          </a:p>
-          <a:p>
-            <a:pPr>
-              <a:lnSpc>
-                <a:spcPct val="120000"/>
-              </a:lnSpc>
-              <a:spcAft>
-                <a:spcPts val="1200"/>
-              </a:spcAft>
-            </a:pPr>
-            <a:r>
-              <a:rPr sz="1400" b="1" i="0">
-                <a:solidFill>
-                  <a:srgbClr val="8A2D1F"/>
-                </a:solidFill>
-                <a:latin typeface="Inter"/>
-              </a:rPr>
-              <a:t>■  </a:t>
-            </a:r>
-            <a:r>
-              <a:rPr sz="1700" b="1" i="0">
-                <a:solidFill>
-                  <a:srgbClr val="1F1F1B"/>
-                </a:solidFill>
-                <a:latin typeface="Inter"/>
-              </a:rPr>
-              <a:t>Prakiraan gempa susulan. </a:t>
-            </a:r>
-            <a:r>
-              <a:rPr sz="1700" b="0" i="0">
-                <a:solidFill>
-                  <a:srgbClr val="1F1F1B"/>
-                </a:solidFill>
-                <a:latin typeface="Inter"/>
-              </a:rPr>
-              <a:t>Melindungi penyintas dan relawan yang masuk ke bangunan retak.</a:t>
-            </a:r>
-          </a:p>
-        </p:txBody>
-      </p:sp>
-      <p:sp>
-        <p:nvSpPr>
-          <p:cNvPr id="6" name="Rectangle 5"/>
+              <a:t>Jejak gempa &amp; tsunami NTT tersebar luas — jauh sebelum 1877</a:t>
+            </a:r>
+          </a:p>
+        </p:txBody>
+      </p:sp>
+      <p:sp>
+        <p:nvSpPr>
+          <p:cNvPr id="5" name="Rectangle 4"/>
           <p:cNvSpPr/>
           <p:nvPr/>
         </p:nvSpPr>
         <p:spPr>
           <a:xfrm>
-            <a:off x="566928" y="4572000"/>
-            <a:ext cx="11064240" cy="1371600"/>
+            <a:off x="548640" y="1600200"/>
+            <a:ext cx="11091672" cy="4343400"/>
           </a:xfrm>
           <a:prstGeom prst="rect">
             <a:avLst/>
           </a:prstGeom>
           <a:solidFill>
-            <a:srgbClr val="F1EEE7"/>
+            <a:srgbClr val="FFFFFF"/>
           </a:solidFill>
-          <a:ln>
-            <a:noFill/>
+          <a:ln w="12700">
+            <a:solidFill>
+              <a:srgbClr val="D8D2C5"/>
+            </a:solidFill>
           </a:ln>
           <a:effectLst/>
         </p:spPr>
@@ -7734,60 +8084,40 @@
           </a:p>
         </p:txBody>
       </p:sp>
-      <p:sp>
-        <p:nvSpPr>
-          <p:cNvPr id="7" name="Rectangle 6"/>
-          <p:cNvSpPr/>
-          <p:nvPr/>
-        </p:nvSpPr>
-        <p:spPr>
-          <a:xfrm>
-            <a:off x="566928" y="4572000"/>
-            <a:ext cx="54864" cy="1371600"/>
-          </a:xfrm>
-          <a:prstGeom prst="rect">
-            <a:avLst/>
-          </a:prstGeom>
-          <a:solidFill>
-            <a:srgbClr val="2F5D62"/>
-          </a:solidFill>
-          <a:ln>
-            <a:noFill/>
-          </a:ln>
-          <a:effectLst/>
-        </p:spPr>
-        <p:style>
-          <a:lnRef idx="1">
-            <a:schemeClr val="accent1"/>
-          </a:lnRef>
-          <a:fillRef idx="3">
-            <a:schemeClr val="accent1"/>
-          </a:fillRef>
-          <a:effectRef idx="2">
-            <a:schemeClr val="accent1"/>
-          </a:effectRef>
-          <a:fontRef idx="minor">
-            <a:schemeClr val="lt1"/>
-          </a:fontRef>
-        </p:style>
-        <p:txBody>
-          <a:bodyPr rtlCol="0" anchor="ctr"/>
-          <a:lstStyle/>
-          <a:p>
-            <a:pPr algn="ctr"/>
-          </a:p>
-        </p:txBody>
-      </p:sp>
-      <p:sp>
-        <p:nvSpPr>
-          <p:cNvPr id="8" name="TextBox 7"/>
+      <p:pic>
+        <p:nvPicPr>
+          <p:cNvPr id="6" name="Picture 5" descr="wichmann_historical_map.png"/>
+          <p:cNvPicPr>
+            <a:picLocks noChangeAspect="1"/>
+          </p:cNvPicPr>
+          <p:nvPr/>
+        </p:nvPicPr>
+        <p:blipFill>
+          <a:blip r:embed="rId2"/>
+          <a:stretch>
+            <a:fillRect/>
+          </a:stretch>
+        </p:blipFill>
+        <p:spPr>
+          <a:xfrm>
+            <a:off x="3534156" y="1737360"/>
+            <a:ext cx="5120640" cy="3840480"/>
+          </a:xfrm>
+          <a:prstGeom prst="rect">
+            <a:avLst/>
+          </a:prstGeom>
+        </p:spPr>
+      </p:pic>
+      <p:sp>
+        <p:nvSpPr>
+          <p:cNvPr id="7" name="TextBox 6"/>
           <p:cNvSpPr txBox="1"/>
           <p:nvPr/>
         </p:nvSpPr>
         <p:spPr>
           <a:xfrm>
-            <a:off x="822960" y="4773168"/>
-            <a:ext cx="10607040" cy="1005840"/>
+            <a:off x="685800" y="5623560"/>
+            <a:ext cx="10515600" cy="365760"/>
           </a:xfrm>
           <a:prstGeom prst="rect">
             <a:avLst/>
@@ -7800,60 +8130,21 @@
           </a:bodyPr>
           <a:lstStyle/>
           <a:p>
-            <a:pPr>
-              <a:spcAft>
-                <a:spcPts val="600"/>
-              </a:spcAft>
-            </a:pPr>
-            <a:r>
-              <a:rPr sz="1200" b="1" i="0">
-                <a:solidFill>
-                  <a:srgbClr val="2F5D62"/>
-                </a:solidFill>
-                <a:latin typeface="Inter"/>
-              </a:rPr>
-              <a:t>KECEPATAN VS KETELITIAN</a:t>
-            </a:r>
-          </a:p>
-          <a:p>
-            <a:pPr>
-              <a:lnSpc>
-                <a:spcPct val="125000"/>
-              </a:lnSpc>
-            </a:pPr>
-            <a:r>
-              <a:rPr sz="1600" b="0" i="0">
-                <a:solidFill>
-                  <a:srgbClr val="1F1F1B"/>
-                </a:solidFill>
-                <a:latin typeface="Inter"/>
-              </a:rPr>
-              <a:t>Mw 7,7 (USGS) vs 7,61 (GFZ); 10 km vs 25 km. Magnitudo </a:t>
-            </a:r>
-            <a:r>
-              <a:rPr sz="1600" b="1" i="0">
-                <a:solidFill>
-                  <a:srgbClr val="1F1F1B"/>
-                </a:solidFill>
-                <a:latin typeface="Inter"/>
-              </a:rPr>
-              <a:t>direvisi</a:t>
-            </a:r>
-            <a:r>
-              <a:rPr sz="1600" b="0" i="0">
-                <a:solidFill>
-                  <a:srgbClr val="1F1F1B"/>
-                </a:solidFill>
-                <a:latin typeface="Inter"/>
-              </a:rPr>
-              <a:t> seiring data masuk — ini normal, bukan kesalahan. Publik perlu memahaminya.</a:t>
-            </a:r>
-          </a:p>
-        </p:txBody>
-      </p:sp>
-      <p:sp>
-        <p:nvSpPr>
-          <p:cNvPr id="9" name="TextBox 8"/>
+            <a:r>
+              <a:rPr sz="1250" b="0" i="0">
+                <a:solidFill>
+                  <a:srgbClr val="5F625C"/>
+                </a:solidFill>
+                <a:latin typeface="Inter"/>
+              </a:rPr>
+              <a:t>Lokasi perkiraan kejadian utama hingga 1877 — gempa darat/pesisir, seaquake/tsunami, peristiwa regional. Sumber: katalog A. Wichmann.</a:t>
+            </a:r>
+          </a:p>
+        </p:txBody>
+      </p:sp>
+      <p:sp>
+        <p:nvSpPr>
+          <p:cNvPr id="8" name="TextBox 7"/>
           <p:cNvSpPr txBox="1"/>
           <p:nvPr/>
         </p:nvSpPr>
@@ -7880,14 +8171,14 @@
                 </a:solidFill>
                 <a:latin typeface="Inter"/>
               </a:rPr>
-              <a:t>Peran geofisika dalam rantai tanggap darurat</a:t>
-            </a:r>
-          </a:p>
-        </p:txBody>
-      </p:sp>
-      <p:sp>
-        <p:nvSpPr>
-          <p:cNvPr id="10" name="TextBox 9"/>
+              <a:t>Sumber: A. Wichmann, katalog gempa Kepulauan Hindia (hingga 1877)</a:t>
+            </a:r>
+          </a:p>
+        </p:txBody>
+      </p:sp>
+      <p:sp>
+        <p:nvSpPr>
+          <p:cNvPr id="9" name="TextBox 8"/>
           <p:cNvSpPr txBox="1"/>
           <p:nvPr/>
         </p:nvSpPr>
@@ -7915,7 +8206,7 @@
                 </a:solidFill>
                 <a:latin typeface="Inter"/>
               </a:rPr>
-              <a:t>7 / 10</a:t>
+              <a:t>7 / 11</a:t>
             </a:r>
           </a:p>
         </p:txBody>
@@ -8007,11 +8298,11 @@
             <a:r>
               <a:rPr sz="1300" b="1" i="0" spc="900">
                 <a:solidFill>
-                  <a:srgbClr val="8A2D1F"/>
-                </a:solidFill>
-                <a:latin typeface="Inter"/>
-              </a:rPr>
-              <a:t>REKAMAN LANGSUNG — GE.MMRI, MAUMERE</a:t>
+                  <a:srgbClr val="2F5D62"/>
+                </a:solidFill>
+                <a:latin typeface="Inter"/>
+              </a:rPr>
+              <a:t>72 JAM PERTAMA</a:t>
             </a:r>
           </a:p>
         </p:txBody>
@@ -8025,7 +8316,7 @@
         <p:spPr>
           <a:xfrm>
             <a:off x="548640" y="868680"/>
-            <a:ext cx="11155680" cy="914400"/>
+            <a:ext cx="10972800" cy="640080"/>
           </a:xfrm>
           <a:prstGeom prst="rect">
             <a:avLst/>
@@ -8038,227 +8329,28 @@
           </a:bodyPr>
           <a:lstStyle/>
           <a:p>
-            <a:pPr>
-              <a:lnSpc>
-                <a:spcPct val="105000"/>
-              </a:lnSpc>
-            </a:pPr>
-            <a:r>
-              <a:rPr sz="2500" b="1" i="0">
+            <a:r>
+              <a:rPr sz="2600" b="1" i="0">
                 <a:solidFill>
                   <a:srgbClr val="1F1F1B"/>
                 </a:solidFill>
                 <a:latin typeface="Source Serif 4"/>
               </a:rPr>
-              <a:t>Guncangan yang meruntuhkan Pelabuhan Maumere, terekam ±104 km dari sumber</a:t>
-            </a:r>
-          </a:p>
-        </p:txBody>
-      </p:sp>
-      <p:sp>
-        <p:nvSpPr>
-          <p:cNvPr id="5" name="Rectangle 4"/>
-          <p:cNvSpPr/>
-          <p:nvPr/>
-        </p:nvSpPr>
-        <p:spPr>
-          <a:xfrm>
-            <a:off x="548640" y="1828800"/>
-            <a:ext cx="6720840" cy="4114800"/>
-          </a:xfrm>
-          <a:prstGeom prst="rect">
-            <a:avLst/>
-          </a:prstGeom>
-          <a:solidFill>
-            <a:srgbClr val="FFFFFF"/>
-          </a:solidFill>
-          <a:ln w="12700">
-            <a:solidFill>
-              <a:srgbClr val="D8D2C5"/>
-            </a:solidFill>
-          </a:ln>
-          <a:effectLst/>
-        </p:spPr>
-        <p:style>
-          <a:lnRef idx="1">
-            <a:schemeClr val="accent1"/>
-          </a:lnRef>
-          <a:fillRef idx="3">
-            <a:schemeClr val="accent1"/>
-          </a:fillRef>
-          <a:effectRef idx="2">
-            <a:schemeClr val="accent1"/>
-          </a:effectRef>
-          <a:fontRef idx="minor">
-            <a:schemeClr val="lt1"/>
-          </a:fontRef>
-        </p:style>
-        <p:txBody>
-          <a:bodyPr rtlCol="0" anchor="ctr"/>
-          <a:lstStyle/>
-          <a:p>
-            <a:pPr algn="ctr"/>
-          </a:p>
-        </p:txBody>
-      </p:sp>
-      <p:pic>
-        <p:nvPicPr>
-          <p:cNvPr id="6" name="Picture 5" descr="waveform_mmri_flores2026.png"/>
-          <p:cNvPicPr>
-            <a:picLocks noChangeAspect="1"/>
-          </p:cNvPicPr>
-          <p:nvPr/>
-        </p:nvPicPr>
-        <p:blipFill>
-          <a:blip r:embed="rId2"/>
-          <a:stretch>
-            <a:fillRect/>
-          </a:stretch>
-        </p:blipFill>
-        <p:spPr>
-          <a:xfrm>
-            <a:off x="658368" y="1938528"/>
-            <a:ext cx="6492240" cy="5553138"/>
-          </a:xfrm>
-          <a:prstGeom prst="rect">
-            <a:avLst/>
-          </a:prstGeom>
-        </p:spPr>
-      </p:pic>
-      <p:sp>
-        <p:nvSpPr>
-          <p:cNvPr id="7" name="TextBox 6"/>
+              <a:t>Apa yang dikerjakan seismologi saat tanggap darurat</a:t>
+            </a:r>
+          </a:p>
+        </p:txBody>
+      </p:sp>
+      <p:sp>
+        <p:nvSpPr>
+          <p:cNvPr id="5" name="TextBox 4"/>
           <p:cNvSpPr txBox="1"/>
           <p:nvPr/>
         </p:nvSpPr>
         <p:spPr>
           <a:xfrm>
-            <a:off x="658368" y="5532120"/>
-            <a:ext cx="6492240" cy="365760"/>
-          </a:xfrm>
-          <a:prstGeom prst="rect">
-            <a:avLst/>
-          </a:prstGeom>
-          <a:noFill/>
-        </p:spPr>
-        <p:txBody>
-          <a:bodyPr wrap="square" anchor="t" lIns="0" rIns="0" tIns="0" bIns="0">
-            <a:spAutoFit/>
-          </a:bodyPr>
-          <a:lstStyle/>
-          <a:p>
-            <a:r>
-              <a:rPr sz="1200" b="0" i="0">
-                <a:solidFill>
-                  <a:srgbClr val="5F625C"/>
-                </a:solidFill>
-                <a:latin typeface="Inter"/>
-              </a:rPr>
-              <a:t>GE.MMRI (8,64°S 122,24°E), broadband + akselerometer, Δ≈104 km. Data: GEOFON · ObsPy.</a:t>
-            </a:r>
-          </a:p>
-        </p:txBody>
-      </p:sp>
-      <p:sp>
-        <p:nvSpPr>
-          <p:cNvPr id="8" name="TextBox 7"/>
-          <p:cNvSpPr txBox="1"/>
-          <p:nvPr/>
-        </p:nvSpPr>
-        <p:spPr>
-          <a:xfrm>
-            <a:off x="7635240" y="1965960"/>
-            <a:ext cx="2103120" cy="1097280"/>
-          </a:xfrm>
-          <a:prstGeom prst="rect">
-            <a:avLst/>
-          </a:prstGeom>
-          <a:noFill/>
-        </p:spPr>
-        <p:txBody>
-          <a:bodyPr wrap="square" anchor="t" lIns="0" rIns="0" tIns="0" bIns="0">
-            <a:spAutoFit/>
-          </a:bodyPr>
-          <a:lstStyle/>
-          <a:p>
-            <a:r>
-              <a:rPr sz="4000" b="1" i="0">
-                <a:solidFill>
-                  <a:srgbClr val="8A2D1F"/>
-                </a:solidFill>
-                <a:latin typeface="Source Serif 4"/>
-              </a:rPr>
-              <a:t>0,14 g</a:t>
-            </a:r>
-          </a:p>
-          <a:p>
-            <a:r>
-              <a:rPr sz="1400" b="0" i="0">
-                <a:solidFill>
-                  <a:srgbClr val="5F625C"/>
-                </a:solidFill>
-                <a:latin typeface="Inter"/>
-              </a:rPr>
-              <a:t>PGA (akselerometer)</a:t>
-            </a:r>
-          </a:p>
-        </p:txBody>
-      </p:sp>
-      <p:sp>
-        <p:nvSpPr>
-          <p:cNvPr id="9" name="TextBox 8"/>
-          <p:cNvSpPr txBox="1"/>
-          <p:nvPr/>
-        </p:nvSpPr>
-        <p:spPr>
-          <a:xfrm>
-            <a:off x="9875520" y="1965960"/>
-            <a:ext cx="2103120" cy="1097280"/>
-          </a:xfrm>
-          <a:prstGeom prst="rect">
-            <a:avLst/>
-          </a:prstGeom>
-          <a:noFill/>
-        </p:spPr>
-        <p:txBody>
-          <a:bodyPr wrap="square" anchor="t" lIns="0" rIns="0" tIns="0" bIns="0">
-            <a:spAutoFit/>
-          </a:bodyPr>
-          <a:lstStyle/>
-          <a:p>
-            <a:r>
-              <a:rPr sz="4000" b="1" i="0">
-                <a:solidFill>
-                  <a:srgbClr val="8A2D1F"/>
-                </a:solidFill>
-                <a:latin typeface="Source Serif 4"/>
-              </a:rPr>
-              <a:t>1,9 cm/s</a:t>
-            </a:r>
-          </a:p>
-          <a:p>
-            <a:r>
-              <a:rPr sz="1400" b="0" i="0">
-                <a:solidFill>
-                  <a:srgbClr val="5F625C"/>
-                </a:solidFill>
-                <a:latin typeface="Inter"/>
-              </a:rPr>
-              <a:t>PGV puncak</a:t>
-            </a:r>
-          </a:p>
-        </p:txBody>
-      </p:sp>
-      <p:sp>
-        <p:nvSpPr>
-          <p:cNvPr id="10" name="TextBox 9"/>
-          <p:cNvSpPr txBox="1"/>
-          <p:nvPr/>
-        </p:nvSpPr>
-        <p:spPr>
-          <a:xfrm>
-            <a:off x="7635240" y="3520440"/>
-            <a:ext cx="4206240" cy="4572000"/>
+            <a:off x="566928" y="1783080"/>
+            <a:ext cx="10972800" cy="4572000"/>
           </a:xfrm>
           <a:prstGeom prst="rect">
             <a:avLst/>
@@ -8280,31 +8372,31 @@
               </a:spcAft>
             </a:pPr>
             <a:r>
-              <a:rPr sz="1300" b="1" i="0">
-                <a:solidFill>
-                  <a:srgbClr val="2F5D62"/>
+              <a:rPr sz="1400" b="1" i="0">
+                <a:solidFill>
+                  <a:srgbClr val="8A2D1F"/>
                 </a:solidFill>
                 <a:latin typeface="Inter"/>
               </a:rPr>
               <a:t>■  </a:t>
             </a:r>
             <a:r>
-              <a:rPr sz="1600" b="1" i="0">
+              <a:rPr sz="1700" b="1" i="0">
                 <a:solidFill>
                   <a:srgbClr val="1F1F1B"/>
                 </a:solidFill>
                 <a:latin typeface="Inter"/>
               </a:rPr>
-              <a:t>Jeda waktu asal → gelombang P (~15 dtk): </a:t>
-            </a:r>
-            <a:r>
-              <a:rPr sz="1600" b="0" i="0">
+              <a:t>Menit pertama — membaca “telegram” bumi. </a:t>
+            </a:r>
+            <a:r>
+              <a:rPr sz="1700" b="0" i="0">
                 <a:solidFill>
                   <a:srgbClr val="1F1F1B"/>
                 </a:solidFill>
                 <a:latin typeface="Inter"/>
               </a:rPr>
-              <a:t>gelombang butuh waktu menempuh 104 km.</a:t>
+              <a:t>Gelombang P tiba lebih dulu, membawa lokasi, kedalaman, magnitudo, dan mekanisme dalam hitungan menit.</a:t>
             </a:r>
           </a:p>
           <a:p>
@@ -8317,45 +8409,207 @@
               </a:spcAft>
             </a:pPr>
             <a:r>
-              <a:rPr sz="1300" b="1" i="0">
-                <a:solidFill>
-                  <a:srgbClr val="2F5D62"/>
+              <a:rPr sz="1400" b="1" i="0">
+                <a:solidFill>
+                  <a:srgbClr val="8A2D1F"/>
                 </a:solidFill>
                 <a:latin typeface="Inter"/>
               </a:rPr>
               <a:t>■  </a:t>
             </a:r>
             <a:r>
-              <a:rPr sz="1600" b="1" i="0">
+              <a:rPr sz="1700" b="1" i="0">
                 <a:solidFill>
                   <a:srgbClr val="1F1F1B"/>
                 </a:solidFill>
                 <a:latin typeface="Inter"/>
               </a:rPr>
-              <a:t>Rekaman ini “menyaksikan” runtuhnya terminal Pelabuhan Maumere</a:t>
-            </a:r>
-            <a:r>
-              <a:rPr sz="1600" b="0" i="0">
+              <a:t>ShakeMap. </a:t>
+            </a:r>
+            <a:r>
+              <a:rPr sz="1700" b="0" i="0">
                 <a:solidFill>
                   <a:srgbClr val="1F1F1B"/>
                 </a:solidFill>
                 <a:latin typeface="Inter"/>
               </a:rPr>
-              <a:t> — jembatan ke dampak struktural.</a:t>
-            </a:r>
-          </a:p>
-        </p:txBody>
-      </p:sp>
-      <p:sp>
-        <p:nvSpPr>
-          <p:cNvPr id="11" name="TextBox 10"/>
+              <a:t>Dari satu sumber, kita petakan sebaran guncangan — menebak di mana kerusakan terparah sebelum laporan masuk, untuk mengarahkan SAR.</a:t>
+            </a:r>
+          </a:p>
+          <a:p>
+            <a:pPr>
+              <a:lnSpc>
+                <a:spcPct val="120000"/>
+              </a:lnSpc>
+              <a:spcAft>
+                <a:spcPts val="1200"/>
+              </a:spcAft>
+            </a:pPr>
+            <a:r>
+              <a:rPr sz="1400" b="1" i="0">
+                <a:solidFill>
+                  <a:srgbClr val="8A2D1F"/>
+                </a:solidFill>
+                <a:latin typeface="Inter"/>
+              </a:rPr>
+              <a:t>■  </a:t>
+            </a:r>
+            <a:r>
+              <a:rPr sz="1700" b="1" i="0">
+                <a:solidFill>
+                  <a:srgbClr val="1F1F1B"/>
+                </a:solidFill>
+                <a:latin typeface="Inter"/>
+              </a:rPr>
+              <a:t>Peringatan tsunami. </a:t>
+            </a:r>
+            <a:r>
+              <a:rPr sz="1700" b="0" i="0">
+                <a:solidFill>
+                  <a:srgbClr val="1F1F1B"/>
+                </a:solidFill>
+                <a:latin typeface="Inter"/>
+              </a:rPr>
+              <a:t>Keputusan besar diambil di menit-menit awal (lihat: 2 menit 16 detik).</a:t>
+            </a:r>
+          </a:p>
+          <a:p>
+            <a:pPr>
+              <a:lnSpc>
+                <a:spcPct val="120000"/>
+              </a:lnSpc>
+              <a:spcAft>
+                <a:spcPts val="1200"/>
+              </a:spcAft>
+            </a:pPr>
+            <a:r>
+              <a:rPr sz="1400" b="1" i="0">
+                <a:solidFill>
+                  <a:srgbClr val="8A2D1F"/>
+                </a:solidFill>
+                <a:latin typeface="Inter"/>
+              </a:rPr>
+              <a:t>■  </a:t>
+            </a:r>
+            <a:r>
+              <a:rPr sz="1700" b="1" i="0">
+                <a:solidFill>
+                  <a:srgbClr val="1F1F1B"/>
+                </a:solidFill>
+                <a:latin typeface="Inter"/>
+              </a:rPr>
+              <a:t>Prakiraan gempa susulan. </a:t>
+            </a:r>
+            <a:r>
+              <a:rPr sz="1700" b="0" i="0">
+                <a:solidFill>
+                  <a:srgbClr val="1F1F1B"/>
+                </a:solidFill>
+                <a:latin typeface="Inter"/>
+              </a:rPr>
+              <a:t>Melindungi penyintas dan relawan yang masuk ke bangunan retak.</a:t>
+            </a:r>
+          </a:p>
+        </p:txBody>
+      </p:sp>
+      <p:sp>
+        <p:nvSpPr>
+          <p:cNvPr id="6" name="Rectangle 5"/>
+          <p:cNvSpPr/>
+          <p:nvPr/>
+        </p:nvSpPr>
+        <p:spPr>
+          <a:xfrm>
+            <a:off x="566928" y="4572000"/>
+            <a:ext cx="11064240" cy="1371600"/>
+          </a:xfrm>
+          <a:prstGeom prst="rect">
+            <a:avLst/>
+          </a:prstGeom>
+          <a:solidFill>
+            <a:srgbClr val="F1EEE7"/>
+          </a:solidFill>
+          <a:ln>
+            <a:noFill/>
+          </a:ln>
+          <a:effectLst/>
+        </p:spPr>
+        <p:style>
+          <a:lnRef idx="1">
+            <a:schemeClr val="accent1"/>
+          </a:lnRef>
+          <a:fillRef idx="3">
+            <a:schemeClr val="accent1"/>
+          </a:fillRef>
+          <a:effectRef idx="2">
+            <a:schemeClr val="accent1"/>
+          </a:effectRef>
+          <a:fontRef idx="minor">
+            <a:schemeClr val="lt1"/>
+          </a:fontRef>
+        </p:style>
+        <p:txBody>
+          <a:bodyPr rtlCol="0" anchor="ctr"/>
+          <a:lstStyle/>
+          <a:p>
+            <a:pPr algn="ctr"/>
+          </a:p>
+        </p:txBody>
+      </p:sp>
+      <p:sp>
+        <p:nvSpPr>
+          <p:cNvPr id="7" name="Rectangle 6"/>
+          <p:cNvSpPr/>
+          <p:nvPr/>
+        </p:nvSpPr>
+        <p:spPr>
+          <a:xfrm>
+            <a:off x="566928" y="4572000"/>
+            <a:ext cx="54864" cy="1371600"/>
+          </a:xfrm>
+          <a:prstGeom prst="rect">
+            <a:avLst/>
+          </a:prstGeom>
+          <a:solidFill>
+            <a:srgbClr val="2F5D62"/>
+          </a:solidFill>
+          <a:ln>
+            <a:noFill/>
+          </a:ln>
+          <a:effectLst/>
+        </p:spPr>
+        <p:style>
+          <a:lnRef idx="1">
+            <a:schemeClr val="accent1"/>
+          </a:lnRef>
+          <a:fillRef idx="3">
+            <a:schemeClr val="accent1"/>
+          </a:fillRef>
+          <a:effectRef idx="2">
+            <a:schemeClr val="accent1"/>
+          </a:effectRef>
+          <a:fontRef idx="minor">
+            <a:schemeClr val="lt1"/>
+          </a:fontRef>
+        </p:style>
+        <p:txBody>
+          <a:bodyPr rtlCol="0" anchor="ctr"/>
+          <a:lstStyle/>
+          <a:p>
+            <a:pPr algn="ctr"/>
+          </a:p>
+        </p:txBody>
+      </p:sp>
+      <p:sp>
+        <p:nvSpPr>
+          <p:cNvPr id="8" name="TextBox 7"/>
           <p:cNvSpPr txBox="1"/>
           <p:nvPr/>
         </p:nvSpPr>
         <p:spPr>
           <a:xfrm>
-            <a:off x="566928" y="6355080"/>
-            <a:ext cx="8229600" cy="365760"/>
+            <a:off x="822960" y="4773168"/>
+            <a:ext cx="10607040" cy="1005840"/>
           </a:xfrm>
           <a:prstGeom prst="rect">
             <a:avLst/>
@@ -8368,28 +8622,67 @@
           </a:bodyPr>
           <a:lstStyle/>
           <a:p>
-            <a:r>
-              <a:rPr sz="1050" b="0" i="0">
-                <a:solidFill>
-                  <a:srgbClr val="5F625C"/>
-                </a:solidFill>
-                <a:latin typeface="Inter"/>
-              </a:rPr>
-              <a:t>Data: GEOFON (GFZ) · workflow ObsPy (adaptasi load.py)</a:t>
-            </a:r>
-          </a:p>
-        </p:txBody>
-      </p:sp>
-      <p:sp>
-        <p:nvSpPr>
-          <p:cNvPr id="12" name="TextBox 11"/>
+            <a:pPr>
+              <a:spcAft>
+                <a:spcPts val="600"/>
+              </a:spcAft>
+            </a:pPr>
+            <a:r>
+              <a:rPr sz="1200" b="1" i="0">
+                <a:solidFill>
+                  <a:srgbClr val="2F5D62"/>
+                </a:solidFill>
+                <a:latin typeface="Inter"/>
+              </a:rPr>
+              <a:t>KECEPATAN VS KETELITIAN</a:t>
+            </a:r>
+          </a:p>
+          <a:p>
+            <a:pPr>
+              <a:lnSpc>
+                <a:spcPct val="125000"/>
+              </a:lnSpc>
+            </a:pPr>
+            <a:r>
+              <a:rPr sz="1600" b="0" i="0">
+                <a:solidFill>
+                  <a:srgbClr val="1F1F1B"/>
+                </a:solidFill>
+                <a:latin typeface="Inter"/>
+              </a:rPr>
+              <a:t>Mw 7,7 (USGS) vs 7,61 (GFZ); 10 km vs 25 km. Magnitudo </a:t>
+            </a:r>
+            <a:r>
+              <a:rPr sz="1600" b="1" i="0">
+                <a:solidFill>
+                  <a:srgbClr val="1F1F1B"/>
+                </a:solidFill>
+                <a:latin typeface="Inter"/>
+              </a:rPr>
+              <a:t>direvisi</a:t>
+            </a:r>
+            <a:r>
+              <a:rPr sz="1600" b="0" i="0">
+                <a:solidFill>
+                  <a:srgbClr val="1F1F1B"/>
+                </a:solidFill>
+                <a:latin typeface="Inter"/>
+              </a:rPr>
+              <a:t> seiring data masuk — ini normal, bukan kesalahan. Publik perlu memahaminya.</a:t>
+            </a:r>
+          </a:p>
+        </p:txBody>
+      </p:sp>
+      <p:sp>
+        <p:nvSpPr>
+          <p:cNvPr id="9" name="TextBox 8"/>
           <p:cNvSpPr txBox="1"/>
           <p:nvPr/>
         </p:nvSpPr>
         <p:spPr>
           <a:xfrm>
-            <a:off x="10789920" y="6355080"/>
-            <a:ext cx="914400" cy="365760"/>
+            <a:off x="566928" y="6355080"/>
+            <a:ext cx="8229600" cy="365760"/>
           </a:xfrm>
           <a:prstGeom prst="rect">
             <a:avLst/>
@@ -8402,6 +8695,40 @@
           </a:bodyPr>
           <a:lstStyle/>
           <a:p>
+            <a:r>
+              <a:rPr sz="1050" b="0" i="0">
+                <a:solidFill>
+                  <a:srgbClr val="5F625C"/>
+                </a:solidFill>
+                <a:latin typeface="Inter"/>
+              </a:rPr>
+              <a:t>Peran geofisika dalam rantai tanggap darurat</a:t>
+            </a:r>
+          </a:p>
+        </p:txBody>
+      </p:sp>
+      <p:sp>
+        <p:nvSpPr>
+          <p:cNvPr id="10" name="TextBox 9"/>
+          <p:cNvSpPr txBox="1"/>
+          <p:nvPr/>
+        </p:nvSpPr>
+        <p:spPr>
+          <a:xfrm>
+            <a:off x="10789920" y="6355080"/>
+            <a:ext cx="914400" cy="365760"/>
+          </a:xfrm>
+          <a:prstGeom prst="rect">
+            <a:avLst/>
+          </a:prstGeom>
+          <a:noFill/>
+        </p:spPr>
+        <p:txBody>
+          <a:bodyPr wrap="square" anchor="t" lIns="0" rIns="0" tIns="0" bIns="0">
+            <a:spAutoFit/>
+          </a:bodyPr>
+          <a:lstStyle/>
+          <a:p>
             <a:pPr algn="r"/>
             <a:r>
               <a:rPr sz="1050" b="0" i="0">
@@ -8410,7 +8737,7 @@
                 </a:solidFill>
                 <a:latin typeface="Inter"/>
               </a:rPr>
-              <a:t>8 / 10</a:t>
+              <a:t>8 / 11</a:t>
             </a:r>
           </a:p>
         </p:txBody>
@@ -8502,11 +8829,11 @@
             <a:r>
               <a:rPr sz="1300" b="1" i="0" spc="900">
                 <a:solidFill>
-                  <a:srgbClr val="2F5D62"/>
-                </a:solidFill>
-                <a:latin typeface="Inter"/>
-              </a:rPr>
-              <a:t>DUA PERTANYAAN YANG PALING DITANYA WARGA</a:t>
+                  <a:srgbClr val="8A2D1F"/>
+                </a:solidFill>
+                <a:latin typeface="Inter"/>
+              </a:rPr>
+              <a:t>REKAMAN LANGSUNG — GE.MMRI, MAUMERE</a:t>
             </a:r>
           </a:p>
         </p:txBody>
@@ -8519,8 +8846,8 @@
         </p:nvSpPr>
         <p:spPr>
           <a:xfrm>
-            <a:off x="548640" y="1280160"/>
-            <a:ext cx="5394960" cy="731520"/>
+            <a:off x="548640" y="868680"/>
+            <a:ext cx="11155680" cy="914400"/>
           </a:xfrm>
           <a:prstGeom prst="rect">
             <a:avLst/>
@@ -8533,28 +8860,227 @@
           </a:bodyPr>
           <a:lstStyle/>
           <a:p>
-            <a:r>
-              <a:rPr sz="2200" b="1" i="0">
+            <a:pPr>
+              <a:lnSpc>
+                <a:spcPct val="105000"/>
+              </a:lnSpc>
+            </a:pPr>
+            <a:r>
+              <a:rPr sz="2500" b="1" i="0">
                 <a:solidFill>
                   <a:srgbClr val="1F1F1B"/>
                 </a:solidFill>
                 <a:latin typeface="Source Serif 4"/>
               </a:rPr>
-              <a:t>“Akan ada susulan yang lebih besar?”</a:t>
-            </a:r>
-          </a:p>
-        </p:txBody>
-      </p:sp>
-      <p:sp>
-        <p:nvSpPr>
-          <p:cNvPr id="5" name="TextBox 4"/>
+              <a:t>Guncangan yang meruntuhkan Pelabuhan Maumere, terekam ±104 km dari sumber</a:t>
+            </a:r>
+          </a:p>
+        </p:txBody>
+      </p:sp>
+      <p:sp>
+        <p:nvSpPr>
+          <p:cNvPr id="5" name="Rectangle 4"/>
+          <p:cNvSpPr/>
+          <p:nvPr/>
+        </p:nvSpPr>
+        <p:spPr>
+          <a:xfrm>
+            <a:off x="548640" y="1828800"/>
+            <a:ext cx="6720840" cy="4114800"/>
+          </a:xfrm>
+          <a:prstGeom prst="rect">
+            <a:avLst/>
+          </a:prstGeom>
+          <a:solidFill>
+            <a:srgbClr val="FFFFFF"/>
+          </a:solidFill>
+          <a:ln w="12700">
+            <a:solidFill>
+              <a:srgbClr val="D8D2C5"/>
+            </a:solidFill>
+          </a:ln>
+          <a:effectLst/>
+        </p:spPr>
+        <p:style>
+          <a:lnRef idx="1">
+            <a:schemeClr val="accent1"/>
+          </a:lnRef>
+          <a:fillRef idx="3">
+            <a:schemeClr val="accent1"/>
+          </a:fillRef>
+          <a:effectRef idx="2">
+            <a:schemeClr val="accent1"/>
+          </a:effectRef>
+          <a:fontRef idx="minor">
+            <a:schemeClr val="lt1"/>
+          </a:fontRef>
+        </p:style>
+        <p:txBody>
+          <a:bodyPr rtlCol="0" anchor="ctr"/>
+          <a:lstStyle/>
+          <a:p>
+            <a:pPr algn="ctr"/>
+          </a:p>
+        </p:txBody>
+      </p:sp>
+      <p:pic>
+        <p:nvPicPr>
+          <p:cNvPr id="6" name="Picture 5" descr="waveform_mmri_flores2026.png"/>
+          <p:cNvPicPr>
+            <a:picLocks noChangeAspect="1"/>
+          </p:cNvPicPr>
+          <p:nvPr/>
+        </p:nvPicPr>
+        <p:blipFill>
+          <a:blip r:embed="rId2"/>
+          <a:stretch>
+            <a:fillRect/>
+          </a:stretch>
+        </p:blipFill>
+        <p:spPr>
+          <a:xfrm>
+            <a:off x="658368" y="1938528"/>
+            <a:ext cx="6492240" cy="5553138"/>
+          </a:xfrm>
+          <a:prstGeom prst="rect">
+            <a:avLst/>
+          </a:prstGeom>
+        </p:spPr>
+      </p:pic>
+      <p:sp>
+        <p:nvSpPr>
+          <p:cNvPr id="7" name="TextBox 6"/>
           <p:cNvSpPr txBox="1"/>
           <p:nvPr/>
         </p:nvSpPr>
         <p:spPr>
           <a:xfrm>
-            <a:off x="566928" y="2194560"/>
-            <a:ext cx="5394960" cy="4572000"/>
+            <a:off x="658368" y="5532120"/>
+            <a:ext cx="6492240" cy="365760"/>
+          </a:xfrm>
+          <a:prstGeom prst="rect">
+            <a:avLst/>
+          </a:prstGeom>
+          <a:noFill/>
+        </p:spPr>
+        <p:txBody>
+          <a:bodyPr wrap="square" anchor="t" lIns="0" rIns="0" tIns="0" bIns="0">
+            <a:spAutoFit/>
+          </a:bodyPr>
+          <a:lstStyle/>
+          <a:p>
+            <a:r>
+              <a:rPr sz="1200" b="0" i="0">
+                <a:solidFill>
+                  <a:srgbClr val="5F625C"/>
+                </a:solidFill>
+                <a:latin typeface="Inter"/>
+              </a:rPr>
+              <a:t>GE.MMRI (8,64°S 122,24°E), broadband + akselerometer, Δ≈104 km. Data: GEOFON · ObsPy.</a:t>
+            </a:r>
+          </a:p>
+        </p:txBody>
+      </p:sp>
+      <p:sp>
+        <p:nvSpPr>
+          <p:cNvPr id="8" name="TextBox 7"/>
+          <p:cNvSpPr txBox="1"/>
+          <p:nvPr/>
+        </p:nvSpPr>
+        <p:spPr>
+          <a:xfrm>
+            <a:off x="7635240" y="1965960"/>
+            <a:ext cx="2103120" cy="1097280"/>
+          </a:xfrm>
+          <a:prstGeom prst="rect">
+            <a:avLst/>
+          </a:prstGeom>
+          <a:noFill/>
+        </p:spPr>
+        <p:txBody>
+          <a:bodyPr wrap="square" anchor="t" lIns="0" rIns="0" tIns="0" bIns="0">
+            <a:spAutoFit/>
+          </a:bodyPr>
+          <a:lstStyle/>
+          <a:p>
+            <a:r>
+              <a:rPr sz="4000" b="1" i="0">
+                <a:solidFill>
+                  <a:srgbClr val="8A2D1F"/>
+                </a:solidFill>
+                <a:latin typeface="Source Serif 4"/>
+              </a:rPr>
+              <a:t>0,14 g</a:t>
+            </a:r>
+          </a:p>
+          <a:p>
+            <a:r>
+              <a:rPr sz="1400" b="0" i="0">
+                <a:solidFill>
+                  <a:srgbClr val="5F625C"/>
+                </a:solidFill>
+                <a:latin typeface="Inter"/>
+              </a:rPr>
+              <a:t>PGA (akselerometer)</a:t>
+            </a:r>
+          </a:p>
+        </p:txBody>
+      </p:sp>
+      <p:sp>
+        <p:nvSpPr>
+          <p:cNvPr id="9" name="TextBox 8"/>
+          <p:cNvSpPr txBox="1"/>
+          <p:nvPr/>
+        </p:nvSpPr>
+        <p:spPr>
+          <a:xfrm>
+            <a:off x="9875520" y="1965960"/>
+            <a:ext cx="2103120" cy="1097280"/>
+          </a:xfrm>
+          <a:prstGeom prst="rect">
+            <a:avLst/>
+          </a:prstGeom>
+          <a:noFill/>
+        </p:spPr>
+        <p:txBody>
+          <a:bodyPr wrap="square" anchor="t" lIns="0" rIns="0" tIns="0" bIns="0">
+            <a:spAutoFit/>
+          </a:bodyPr>
+          <a:lstStyle/>
+          <a:p>
+            <a:r>
+              <a:rPr sz="4000" b="1" i="0">
+                <a:solidFill>
+                  <a:srgbClr val="8A2D1F"/>
+                </a:solidFill>
+                <a:latin typeface="Source Serif 4"/>
+              </a:rPr>
+              <a:t>1,9 cm/s</a:t>
+            </a:r>
+          </a:p>
+          <a:p>
+            <a:r>
+              <a:rPr sz="1400" b="0" i="0">
+                <a:solidFill>
+                  <a:srgbClr val="5F625C"/>
+                </a:solidFill>
+                <a:latin typeface="Inter"/>
+              </a:rPr>
+              <a:t>PGV puncak</a:t>
+            </a:r>
+          </a:p>
+        </p:txBody>
+      </p:sp>
+      <p:sp>
+        <p:nvSpPr>
+          <p:cNvPr id="10" name="TextBox 9"/>
+          <p:cNvSpPr txBox="1"/>
+          <p:nvPr/>
+        </p:nvSpPr>
+        <p:spPr>
+          <a:xfrm>
+            <a:off x="7635240" y="3520440"/>
+            <a:ext cx="4206240" cy="4572000"/>
           </a:xfrm>
           <a:prstGeom prst="rect">
             <a:avLst/>
@@ -8576,31 +9102,31 @@
               </a:spcAft>
             </a:pPr>
             <a:r>
-              <a:rPr sz="1400" b="1" i="0">
-                <a:solidFill>
-                  <a:srgbClr val="8A2D1F"/>
+              <a:rPr sz="1300" b="1" i="0">
+                <a:solidFill>
+                  <a:srgbClr val="2F5D62"/>
                 </a:solidFill>
                 <a:latin typeface="Inter"/>
               </a:rPr>
               <a:t>■  </a:t>
             </a:r>
             <a:r>
-              <a:rPr sz="1700" b="1" i="0">
+              <a:rPr sz="1600" b="1" i="0">
                 <a:solidFill>
                   <a:srgbClr val="1F1F1B"/>
                 </a:solidFill>
                 <a:latin typeface="Inter"/>
               </a:rPr>
-              <a:t>&gt;2.768 susulan</a:t>
-            </a:r>
-            <a:r>
-              <a:rPr sz="1700" b="0" i="0">
+              <a:t>Jeda waktu asal → gelombang P (~15 dtk): </a:t>
+            </a:r>
+            <a:r>
+              <a:rPr sz="1600" b="0" i="0">
                 <a:solidFill>
                   <a:srgbClr val="1F1F1B"/>
                 </a:solidFill>
                 <a:latin typeface="Inter"/>
               </a:rPr>
-              <a:t> mengikuti pola peluruhan (hukum Omori): rapat di awal, mereda seiring waktu.</a:t>
+              <a:t>gelombang butuh waktu menempuh 104 km.</a:t>
             </a:r>
           </a:p>
           <a:p>
@@ -8613,142 +9139,45 @@
               </a:spcAft>
             </a:pPr>
             <a:r>
-              <a:rPr sz="1400" b="1" i="0">
-                <a:solidFill>
-                  <a:srgbClr val="8A2D1F"/>
+              <a:rPr sz="1300" b="1" i="0">
+                <a:solidFill>
+                  <a:srgbClr val="2F5D62"/>
                 </a:solidFill>
                 <a:latin typeface="Inter"/>
               </a:rPr>
               <a:t>■  </a:t>
             </a:r>
             <a:r>
-              <a:rPr sz="1700" b="0" i="0">
+              <a:rPr sz="1600" b="1" i="0">
                 <a:solidFill>
                   <a:srgbClr val="1F1F1B"/>
                 </a:solidFill>
                 <a:latin typeface="Inter"/>
               </a:rPr>
-              <a:t>Peluang susulan besar mengecil tiap hari — tapi </a:t>
-            </a:r>
-            <a:r>
-              <a:rPr sz="1700" b="1" i="0">
+              <a:t>Rekaman ini “menyaksikan” runtuhnya terminal Pelabuhan Maumere</a:t>
+            </a:r>
+            <a:r>
+              <a:rPr sz="1600" b="0" i="0">
                 <a:solidFill>
                   <a:srgbClr val="1F1F1B"/>
                 </a:solidFill>
                 <a:latin typeface="Inter"/>
               </a:rPr>
-              <a:t>tak pernah nol</a:t>
-            </a:r>
-            <a:r>
-              <a:rPr sz="1700" b="0" i="0">
-                <a:solidFill>
-                  <a:srgbClr val="1F1F1B"/>
-                </a:solidFill>
-                <a:latin typeface="Inter"/>
-              </a:rPr>
-              <a:t>. Jangan masuk bangunan retak.</a:t>
-            </a:r>
-          </a:p>
-        </p:txBody>
-      </p:sp>
-      <p:sp>
-        <p:nvSpPr>
-          <p:cNvPr id="6" name="Rectangle 5"/>
-          <p:cNvSpPr/>
-          <p:nvPr/>
-        </p:nvSpPr>
-        <p:spPr>
-          <a:xfrm>
-            <a:off x="6400800" y="1737360"/>
-            <a:ext cx="5212080" cy="2194560"/>
-          </a:xfrm>
-          <a:prstGeom prst="rect">
-            <a:avLst/>
-          </a:prstGeom>
-          <a:solidFill>
-            <a:srgbClr val="F1EEE7"/>
-          </a:solidFill>
-          <a:ln>
-            <a:noFill/>
-          </a:ln>
-          <a:effectLst/>
-        </p:spPr>
-        <p:style>
-          <a:lnRef idx="1">
-            <a:schemeClr val="accent1"/>
-          </a:lnRef>
-          <a:fillRef idx="3">
-            <a:schemeClr val="accent1"/>
-          </a:fillRef>
-          <a:effectRef idx="2">
-            <a:schemeClr val="accent1"/>
-          </a:effectRef>
-          <a:fontRef idx="minor">
-            <a:schemeClr val="lt1"/>
-          </a:fontRef>
-        </p:style>
-        <p:txBody>
-          <a:bodyPr rtlCol="0" anchor="ctr"/>
-          <a:lstStyle/>
-          <a:p>
-            <a:pPr algn="ctr"/>
-          </a:p>
-        </p:txBody>
-      </p:sp>
-      <p:sp>
-        <p:nvSpPr>
-          <p:cNvPr id="7" name="Rectangle 6"/>
-          <p:cNvSpPr/>
-          <p:nvPr/>
-        </p:nvSpPr>
-        <p:spPr>
-          <a:xfrm>
-            <a:off x="6400800" y="1737360"/>
-            <a:ext cx="54864" cy="2194560"/>
-          </a:xfrm>
-          <a:prstGeom prst="rect">
-            <a:avLst/>
-          </a:prstGeom>
-          <a:solidFill>
-            <a:srgbClr val="8A2D1F"/>
-          </a:solidFill>
-          <a:ln>
-            <a:noFill/>
-          </a:ln>
-          <a:effectLst/>
-        </p:spPr>
-        <p:style>
-          <a:lnRef idx="1">
-            <a:schemeClr val="accent1"/>
-          </a:lnRef>
-          <a:fillRef idx="3">
-            <a:schemeClr val="accent1"/>
-          </a:fillRef>
-          <a:effectRef idx="2">
-            <a:schemeClr val="accent1"/>
-          </a:effectRef>
-          <a:fontRef idx="minor">
-            <a:schemeClr val="lt1"/>
-          </a:fontRef>
-        </p:style>
-        <p:txBody>
-          <a:bodyPr rtlCol="0" anchor="ctr"/>
-          <a:lstStyle/>
-          <a:p>
-            <a:pPr algn="ctr"/>
-          </a:p>
-        </p:txBody>
-      </p:sp>
-      <p:sp>
-        <p:nvSpPr>
-          <p:cNvPr id="8" name="TextBox 7"/>
+              <a:t> — jembatan ke dampak struktural.</a:t>
+            </a:r>
+          </a:p>
+        </p:txBody>
+      </p:sp>
+      <p:sp>
+        <p:nvSpPr>
+          <p:cNvPr id="11" name="TextBox 10"/>
           <p:cNvSpPr txBox="1"/>
           <p:nvPr/>
         </p:nvSpPr>
         <p:spPr>
           <a:xfrm>
-            <a:off x="6656832" y="1938528"/>
-            <a:ext cx="4754880" cy="1828800"/>
+            <a:off x="566928" y="6355080"/>
+            <a:ext cx="8229600" cy="365760"/>
           </a:xfrm>
           <a:prstGeom prst="rect">
             <a:avLst/>
@@ -8761,85 +9190,28 @@
           </a:bodyPr>
           <a:lstStyle/>
           <a:p>
-            <a:pPr>
-              <a:spcAft>
-                <a:spcPts val="600"/>
-              </a:spcAft>
-            </a:pPr>
-            <a:r>
-              <a:rPr sz="1200" b="1" i="0">
-                <a:solidFill>
-                  <a:srgbClr val="8A2D1F"/>
-                </a:solidFill>
-                <a:latin typeface="Inter"/>
-              </a:rPr>
-              <a:t>PESAN YANG MENYELAMATKAN</a:t>
-            </a:r>
-          </a:p>
-          <a:p>
-            <a:pPr>
-              <a:lnSpc>
-                <a:spcPct val="125000"/>
-              </a:lnSpc>
-            </a:pPr>
-            <a:r>
-              <a:rPr sz="1600" b="0" i="0">
-                <a:solidFill>
-                  <a:srgbClr val="1F1F1B"/>
-                </a:solidFill>
-                <a:latin typeface="Inter"/>
-              </a:rPr>
-              <a:t>Untuk tsunami dekat-pantai, </a:t>
-            </a:r>
-            <a:r>
-              <a:rPr sz="1600" b="1" i="0">
-                <a:solidFill>
-                  <a:srgbClr val="1F1F1B"/>
-                </a:solidFill>
-                <a:latin typeface="Inter"/>
-              </a:rPr>
-              <a:t>guncangan kuat itu sendiri adalah peringatan.</a:t>
-            </a:r>
-            <a:r>
-              <a:rPr sz="1600" b="0" i="0">
-                <a:solidFill>
-                  <a:srgbClr val="1F1F1B"/>
-                </a:solidFill>
-                <a:latin typeface="Inter"/>
-              </a:rPr>
-              <a:t> Jangan tunggu sirene — </a:t>
-            </a:r>
-            <a:r>
-              <a:rPr sz="1600" b="1" i="0">
-                <a:solidFill>
-                  <a:srgbClr val="1F1F1B"/>
-                </a:solidFill>
-                <a:latin typeface="Inter"/>
-              </a:rPr>
-              <a:t>segera evakuasi mandiri</a:t>
-            </a:r>
-            <a:r>
-              <a:rPr sz="1600" b="0" i="0">
-                <a:solidFill>
-                  <a:srgbClr val="1F1F1B"/>
-                </a:solidFill>
-                <a:latin typeface="Inter"/>
-              </a:rPr>
-              <a:t> ke tempat tinggi.</a:t>
-            </a:r>
-          </a:p>
-        </p:txBody>
-      </p:sp>
-      <p:sp>
-        <p:nvSpPr>
-          <p:cNvPr id="9" name="TextBox 8"/>
+            <a:r>
+              <a:rPr sz="1050" b="0" i="0">
+                <a:solidFill>
+                  <a:srgbClr val="5F625C"/>
+                </a:solidFill>
+                <a:latin typeface="Inter"/>
+              </a:rPr>
+              <a:t>Data: GEOFON (GFZ) · workflow ObsPy (adaptasi load.py)</a:t>
+            </a:r>
+          </a:p>
+        </p:txBody>
+      </p:sp>
+      <p:sp>
+        <p:nvSpPr>
+          <p:cNvPr id="12" name="TextBox 11"/>
           <p:cNvSpPr txBox="1"/>
           <p:nvPr/>
         </p:nvSpPr>
         <p:spPr>
           <a:xfrm>
-            <a:off x="6400800" y="4114800"/>
-            <a:ext cx="5212080" cy="731520"/>
+            <a:off x="10789920" y="6355080"/>
+            <a:ext cx="914400" cy="365760"/>
           </a:xfrm>
           <a:prstGeom prst="rect">
             <a:avLst/>
@@ -8852,83 +9224,15 @@
           </a:bodyPr>
           <a:lstStyle/>
           <a:p>
-            <a:r>
-              <a:rPr sz="1500" b="0" i="1">
+            <a:pPr algn="r"/>
+            <a:r>
+              <a:rPr sz="1050" b="0" i="0">
                 <a:solidFill>
                   <a:srgbClr val="5F625C"/>
                 </a:solidFill>
                 <a:latin typeface="Inter"/>
               </a:rPr>
-              <a:t>1992: tsunami Flores tiba dalam hitungan menit. Waktu adalah nyawa.</a:t>
-            </a:r>
-          </a:p>
-        </p:txBody>
-      </p:sp>
-      <p:sp>
-        <p:nvSpPr>
-          <p:cNvPr id="10" name="TextBox 9"/>
-          <p:cNvSpPr txBox="1"/>
-          <p:nvPr/>
-        </p:nvSpPr>
-        <p:spPr>
-          <a:xfrm>
-            <a:off x="566928" y="6355080"/>
-            <a:ext cx="8229600" cy="365760"/>
-          </a:xfrm>
-          <a:prstGeom prst="rect">
-            <a:avLst/>
-          </a:prstGeom>
-          <a:noFill/>
-        </p:spPr>
-        <p:txBody>
-          <a:bodyPr wrap="square" anchor="t" lIns="0" rIns="0" tIns="0" bIns="0">
-            <a:spAutoFit/>
-          </a:bodyPr>
-          <a:lstStyle/>
-          <a:p>
-            <a:r>
-              <a:rPr sz="1050" b="0" i="0">
-                <a:solidFill>
-                  <a:srgbClr val="5F625C"/>
-                </a:solidFill>
-                <a:latin typeface="Inter"/>
-              </a:rPr>
-              <a:t>Komunikasi risiko saat darurat</a:t>
-            </a:r>
-          </a:p>
-        </p:txBody>
-      </p:sp>
-      <p:sp>
-        <p:nvSpPr>
-          <p:cNvPr id="11" name="TextBox 10"/>
-          <p:cNvSpPr txBox="1"/>
-          <p:nvPr/>
-        </p:nvSpPr>
-        <p:spPr>
-          <a:xfrm>
-            <a:off x="10789920" y="6355080"/>
-            <a:ext cx="914400" cy="365760"/>
-          </a:xfrm>
-          <a:prstGeom prst="rect">
-            <a:avLst/>
-          </a:prstGeom>
-          <a:noFill/>
-        </p:spPr>
-        <p:txBody>
-          <a:bodyPr wrap="square" anchor="t" lIns="0" rIns="0" tIns="0" bIns="0">
-            <a:spAutoFit/>
-          </a:bodyPr>
-          <a:lstStyle/>
-          <a:p>
-            <a:pPr algn="r"/>
-            <a:r>
-              <a:rPr sz="1050" b="0" i="0">
-                <a:solidFill>
-                  <a:srgbClr val="5F625C"/>
-                </a:solidFill>
-                <a:latin typeface="Inter"/>
-              </a:rPr>
-              <a:t>9 / 10</a:t>
+              <a:t>9 / 11</a:t>
             </a:r>
           </a:p>
         </p:txBody>

</xml_diff>